<commit_message>
Add user behavior database evidence to presentation
</commit_message>
<xml_diff>
--- a/발표자료.pptx
+++ b/발표자료.pptx
@@ -24,6 +24,7 @@
     <p:sldId id="272" r:id="rId23"/>
     <p:sldId id="273" r:id="rId24"/>
     <p:sldId id="274" r:id="rId25"/>
+    <p:sldId id="275" r:id="rId26"/>
   </p:sldIdLst>
   <p:sldSz cx="12191695" cy="6858000" type="screen4x3"/>
   <p:notesSz cx="6858000" cy="9144000"/>
@@ -16352,7 +16353,7 @@
                 </a:solidFill>
                 <a:latin typeface="Malgun Gothic"/>
               </a:rPr>
-              <a:t>17 · 결론</a:t>
+              <a:t>17 · 사용자 DB 관리</a:t>
             </a:r>
           </a:p>
         </p:txBody>
@@ -16391,7 +16392,7 @@
                 </a:solidFill>
                 <a:latin typeface="Malgun Gothic"/>
               </a:rPr>
-              <a:t>이 프로젝트를 통해 완성한 것</a:t>
+              <a:t>DBeaver에서 회원과 행동 데이터를 직접 확인</a:t>
             </a:r>
           </a:p>
         </p:txBody>
@@ -16404,8 +16405,122 @@
         </p:nvSpPr>
         <p:spPr>
           <a:xfrm>
-            <a:off x="658368" y="1508760"/>
-            <a:ext cx="5166360" cy="1097280"/>
+            <a:off x="731519" y="1508760"/>
+            <a:ext cx="6839712" cy="3639312"/>
+          </a:xfrm>
+          <a:prstGeom prst="roundRect">
+            <a:avLst>
+              <a:gd name="adj" fmla="val 12000"/>
+            </a:avLst>
+          </a:prstGeom>
+          <a:solidFill>
+            <a:srgbClr val="0F172A"/>
+          </a:solidFill>
+          <a:ln>
+            <a:noFill/>
+          </a:ln>
+        </p:spPr>
+        <p:style>
+          <a:lnRef idx="1">
+            <a:schemeClr val="accent1"/>
+          </a:lnRef>
+          <a:fillRef idx="3">
+            <a:schemeClr val="accent1"/>
+          </a:fillRef>
+          <a:effectRef idx="2">
+            <a:schemeClr val="accent1"/>
+          </a:effectRef>
+          <a:fontRef idx="minor">
+            <a:schemeClr val="lt1"/>
+          </a:fontRef>
+        </p:style>
+        <p:txBody>
+          <a:bodyPr rtlCol="0" anchor="ctr"/>
+          <a:lstStyle/>
+          <a:p>
+            <a:pPr algn="ctr"/>
+          </a:p>
+        </p:txBody>
+      </p:sp>
+      <p:pic>
+        <p:nvPicPr>
+          <p:cNvPr id="5" name="Picture 4" descr="beginner_dbeaver_1346x716.png"/>
+          <p:cNvPicPr>
+            <a:picLocks noChangeAspect="1"/>
+          </p:cNvPicPr>
+          <p:nvPr/>
+        </p:nvPicPr>
+        <p:blipFill>
+          <a:blip r:embed="rId2"/>
+          <a:stretch>
+            <a:fillRect/>
+          </a:stretch>
+        </p:blipFill>
+        <p:spPr>
+          <a:xfrm>
+            <a:off x="658368" y="1417320"/>
+            <a:ext cx="6839712" cy="3639312"/>
+          </a:xfrm>
+          <a:prstGeom prst="rect">
+            <a:avLst/>
+          </a:prstGeom>
+        </p:spPr>
+      </p:pic>
+      <p:sp>
+        <p:nvSpPr>
+          <p:cNvPr id="6" name="Rounded Rectangle 5"/>
+          <p:cNvSpPr/>
+          <p:nvPr/>
+        </p:nvSpPr>
+        <p:spPr>
+          <a:xfrm>
+            <a:off x="658368" y="1417320"/>
+            <a:ext cx="6839712" cy="3639312"/>
+          </a:xfrm>
+          <a:prstGeom prst="roundRect">
+            <a:avLst>
+              <a:gd name="adj" fmla="val 12000"/>
+            </a:avLst>
+          </a:prstGeom>
+          <a:noFill/>
+          <a:ln w="12700">
+            <a:solidFill>
+              <a:srgbClr val="D9DEEA"/>
+            </a:solidFill>
+          </a:ln>
+        </p:spPr>
+        <p:style>
+          <a:lnRef idx="1">
+            <a:schemeClr val="accent1"/>
+          </a:lnRef>
+          <a:fillRef idx="3">
+            <a:schemeClr val="accent1"/>
+          </a:fillRef>
+          <a:effectRef idx="2">
+            <a:schemeClr val="accent1"/>
+          </a:effectRef>
+          <a:fontRef idx="minor">
+            <a:schemeClr val="lt1"/>
+          </a:fontRef>
+        </p:style>
+        <p:txBody>
+          <a:bodyPr rtlCol="0" anchor="ctr"/>
+          <a:lstStyle/>
+          <a:p>
+            <a:pPr algn="ctr"/>
+          </a:p>
+        </p:txBody>
+      </p:sp>
+      <p:sp>
+        <p:nvSpPr>
+          <p:cNvPr id="7" name="Rounded Rectangle 6"/>
+          <p:cNvSpPr/>
+          <p:nvPr/>
+        </p:nvSpPr>
+        <p:spPr>
+          <a:xfrm>
+            <a:off x="7818120" y="1417320"/>
+            <a:ext cx="3493008" cy="3639312"/>
           </a:xfrm>
           <a:prstGeom prst="roundRect">
             <a:avLst>
@@ -16445,16 +16560,55 @@
       </p:sp>
       <p:sp>
         <p:nvSpPr>
-          <p:cNvPr id="5" name="Rectangle 4"/>
+          <p:cNvPr id="8" name="TextBox 7"/>
+          <p:cNvSpPr txBox="1"/>
+          <p:nvPr/>
+        </p:nvSpPr>
+        <p:spPr>
+          <a:xfrm>
+            <a:off x="8110727" y="1691640"/>
+            <a:ext cx="1463040" cy="310896"/>
+          </a:xfrm>
+          <a:prstGeom prst="rect">
+            <a:avLst/>
+          </a:prstGeom>
+          <a:noFill/>
+        </p:spPr>
+        <p:txBody>
+          <a:bodyPr wrap="square" lIns="18288" rIns="18288" tIns="18288" bIns="18288" anchor="t">
+            <a:spAutoFit/>
+          </a:bodyPr>
+          <a:lstStyle/>
+          <a:p>
+            <a:pPr algn="l">
+              <a:lnSpc>
+                <a:spcPct val="108000"/>
+              </a:lnSpc>
+            </a:pPr>
+            <a:r>
+              <a:rPr sz="1700" b="1">
+                <a:solidFill>
+                  <a:srgbClr val="6246EA"/>
+                </a:solidFill>
+                <a:latin typeface="Malgun Gothic"/>
+              </a:rPr>
+              <a:t>조회 과정</a:t>
+            </a:r>
+          </a:p>
+        </p:txBody>
+      </p:sp>
+      <p:sp>
+        <p:nvSpPr>
+          <p:cNvPr id="9" name="Oval 8"/>
           <p:cNvSpPr/>
           <p:nvPr/>
         </p:nvSpPr>
         <p:spPr>
           <a:xfrm>
-            <a:off x="658368" y="1508760"/>
-            <a:ext cx="91440" cy="1097280"/>
-          </a:xfrm>
-          <a:prstGeom prst="rect">
+            <a:off x="8119872" y="2176272"/>
+            <a:ext cx="420624" cy="420624"/>
+          </a:xfrm>
+          <a:prstGeom prst="ellipse">
             <a:avLst/>
           </a:prstGeom>
           <a:solidFill>
@@ -16488,14 +16642,53 @@
       </p:sp>
       <p:sp>
         <p:nvSpPr>
-          <p:cNvPr id="6" name="TextBox 5"/>
-          <p:cNvSpPr txBox="1"/>
-          <p:nvPr/>
-        </p:nvSpPr>
-        <p:spPr>
-          <a:xfrm>
-            <a:off x="914400" y="1691639"/>
-            <a:ext cx="4663440" cy="274320"/>
+          <p:cNvPr id="10" name="TextBox 9"/>
+          <p:cNvSpPr txBox="1"/>
+          <p:nvPr/>
+        </p:nvSpPr>
+        <p:spPr>
+          <a:xfrm>
+            <a:off x="8119872" y="2176272"/>
+            <a:ext cx="420624" cy="420624"/>
+          </a:xfrm>
+          <a:prstGeom prst="rect">
+            <a:avLst/>
+          </a:prstGeom>
+          <a:noFill/>
+        </p:spPr>
+        <p:txBody>
+          <a:bodyPr wrap="square" lIns="18288" rIns="18288" tIns="18288" bIns="18288" anchor="ctr">
+            <a:spAutoFit/>
+          </a:bodyPr>
+          <a:lstStyle/>
+          <a:p>
+            <a:pPr algn="ctr">
+              <a:lnSpc>
+                <a:spcPct val="108000"/>
+              </a:lnSpc>
+            </a:pPr>
+            <a:r>
+              <a:rPr sz="1300" b="1">
+                <a:solidFill>
+                  <a:srgbClr val="FFFFFF"/>
+                </a:solidFill>
+                <a:latin typeface="Malgun Gothic"/>
+              </a:rPr>
+              <a:t>1</a:t>
+            </a:r>
+          </a:p>
+        </p:txBody>
+      </p:sp>
+      <p:sp>
+        <p:nvSpPr>
+          <p:cNvPr id="11" name="TextBox 10"/>
+          <p:cNvSpPr txBox="1"/>
+          <p:nvPr/>
+        </p:nvSpPr>
+        <p:spPr>
+          <a:xfrm>
+            <a:off x="8705088" y="2194560"/>
+            <a:ext cx="1325880" cy="246888"/>
           </a:xfrm>
           <a:prstGeom prst="rect">
             <a:avLst/>
@@ -16514,27 +16707,27 @@
               </a:lnSpc>
             </a:pPr>
             <a:r>
-              <a:rPr sz="1400" b="1">
-                <a:solidFill>
-                  <a:srgbClr val="6246EA"/>
-                </a:solidFill>
-                <a:latin typeface="Malgun Gothic"/>
-              </a:rPr>
-              <a:t>하나의 완성된 서비스</a:t>
-            </a:r>
-          </a:p>
-        </p:txBody>
-      </p:sp>
-      <p:sp>
-        <p:nvSpPr>
-          <p:cNvPr id="7" name="TextBox 6"/>
-          <p:cNvSpPr txBox="1"/>
-          <p:nvPr/>
-        </p:nvSpPr>
-        <p:spPr>
-          <a:xfrm>
-            <a:off x="914400" y="2039112"/>
-            <a:ext cx="4663440" cy="475487"/>
+              <a:rPr sz="1050" b="1">
+                <a:solidFill>
+                  <a:srgbClr val="0F172A"/>
+                </a:solidFill>
+                <a:latin typeface="Malgun Gothic"/>
+              </a:rPr>
+              <a:t>Aiven MySQL 연결</a:t>
+            </a:r>
+          </a:p>
+        </p:txBody>
+      </p:sp>
+      <p:sp>
+        <p:nvSpPr>
+          <p:cNvPr id="12" name="TextBox 11"/>
+          <p:cNvSpPr txBox="1"/>
+          <p:nvPr/>
+        </p:nvSpPr>
+        <p:spPr>
+          <a:xfrm>
+            <a:off x="10012680" y="2194560"/>
+            <a:ext cx="960120" cy="365760"/>
           </a:xfrm>
           <a:prstGeom prst="rect">
             <a:avLst/>
@@ -16553,40 +16746,36 @@
               </a:lnSpc>
             </a:pPr>
             <a:r>
-              <a:rPr sz="1030" b="1">
-                <a:solidFill>
-                  <a:srgbClr val="111827"/>
-                </a:solidFill>
-                <a:latin typeface="Malgun Gothic"/>
-              </a:rPr>
-              <a:t>로그인부터 추천·주문·취소·후기까지 연결</a:t>
-            </a:r>
-          </a:p>
-        </p:txBody>
-      </p:sp>
-      <p:sp>
-        <p:nvSpPr>
-          <p:cNvPr id="8" name="Rounded Rectangle 7"/>
+              <a:rPr sz="780" b="1">
+                <a:solidFill>
+                  <a:srgbClr val="64748B"/>
+                </a:solidFill>
+                <a:latin typeface="Malgun Gothic"/>
+              </a:rPr>
+              <a:t>defaultdb 선택</a:t>
+            </a:r>
+          </a:p>
+        </p:txBody>
+      </p:sp>
+      <p:sp>
+        <p:nvSpPr>
+          <p:cNvPr id="13" name="Oval 12"/>
           <p:cNvSpPr/>
           <p:nvPr/>
         </p:nvSpPr>
         <p:spPr>
           <a:xfrm>
-            <a:off x="6190488" y="1508760"/>
-            <a:ext cx="5166360" cy="1097280"/>
-          </a:xfrm>
-          <a:prstGeom prst="roundRect">
-            <a:avLst>
-              <a:gd name="adj" fmla="val 12000"/>
-            </a:avLst>
+            <a:off x="8119872" y="2770632"/>
+            <a:ext cx="420624" cy="420624"/>
+          </a:xfrm>
+          <a:prstGeom prst="ellipse">
+            <a:avLst/>
           </a:prstGeom>
           <a:solidFill>
-            <a:srgbClr val="FFFFFF"/>
+            <a:srgbClr val="2563EB"/>
           </a:solidFill>
-          <a:ln w="12700">
-            <a:solidFill>
-              <a:srgbClr val="D9DEEA"/>
-            </a:solidFill>
+          <a:ln>
+            <a:noFill/>
           </a:ln>
         </p:spPr>
         <p:style>
@@ -16613,16 +16802,133 @@
       </p:sp>
       <p:sp>
         <p:nvSpPr>
-          <p:cNvPr id="9" name="Rectangle 8"/>
+          <p:cNvPr id="14" name="TextBox 13"/>
+          <p:cNvSpPr txBox="1"/>
+          <p:nvPr/>
+        </p:nvSpPr>
+        <p:spPr>
+          <a:xfrm>
+            <a:off x="8119872" y="2770632"/>
+            <a:ext cx="420624" cy="420624"/>
+          </a:xfrm>
+          <a:prstGeom prst="rect">
+            <a:avLst/>
+          </a:prstGeom>
+          <a:noFill/>
+        </p:spPr>
+        <p:txBody>
+          <a:bodyPr wrap="square" lIns="18288" rIns="18288" tIns="18288" bIns="18288" anchor="ctr">
+            <a:spAutoFit/>
+          </a:bodyPr>
+          <a:lstStyle/>
+          <a:p>
+            <a:pPr algn="ctr">
+              <a:lnSpc>
+                <a:spcPct val="108000"/>
+              </a:lnSpc>
+            </a:pPr>
+            <a:r>
+              <a:rPr sz="1300" b="1">
+                <a:solidFill>
+                  <a:srgbClr val="FFFFFF"/>
+                </a:solidFill>
+                <a:latin typeface="Malgun Gothic"/>
+              </a:rPr>
+              <a:t>2</a:t>
+            </a:r>
+          </a:p>
+        </p:txBody>
+      </p:sp>
+      <p:sp>
+        <p:nvSpPr>
+          <p:cNvPr id="15" name="TextBox 14"/>
+          <p:cNvSpPr txBox="1"/>
+          <p:nvPr/>
+        </p:nvSpPr>
+        <p:spPr>
+          <a:xfrm>
+            <a:off x="8705088" y="2788920"/>
+            <a:ext cx="1325880" cy="246888"/>
+          </a:xfrm>
+          <a:prstGeom prst="rect">
+            <a:avLst/>
+          </a:prstGeom>
+          <a:noFill/>
+        </p:spPr>
+        <p:txBody>
+          <a:bodyPr wrap="square" lIns="18288" rIns="18288" tIns="18288" bIns="18288" anchor="t">
+            <a:spAutoFit/>
+          </a:bodyPr>
+          <a:lstStyle/>
+          <a:p>
+            <a:pPr algn="l">
+              <a:lnSpc>
+                <a:spcPct val="108000"/>
+              </a:lnSpc>
+            </a:pPr>
+            <a:r>
+              <a:rPr sz="1050" b="1">
+                <a:solidFill>
+                  <a:srgbClr val="0F172A"/>
+                </a:solidFill>
+                <a:latin typeface="Malgun Gothic"/>
+              </a:rPr>
+              <a:t>SQL 편집기 실행</a:t>
+            </a:r>
+          </a:p>
+        </p:txBody>
+      </p:sp>
+      <p:sp>
+        <p:nvSpPr>
+          <p:cNvPr id="16" name="TextBox 15"/>
+          <p:cNvSpPr txBox="1"/>
+          <p:nvPr/>
+        </p:nvSpPr>
+        <p:spPr>
+          <a:xfrm>
+            <a:off x="10012680" y="2788920"/>
+            <a:ext cx="960120" cy="365760"/>
+          </a:xfrm>
+          <a:prstGeom prst="rect">
+            <a:avLst/>
+          </a:prstGeom>
+          <a:noFill/>
+        </p:spPr>
+        <p:txBody>
+          <a:bodyPr wrap="square" lIns="18288" rIns="18288" tIns="18288" bIns="18288" anchor="t">
+            <a:spAutoFit/>
+          </a:bodyPr>
+          <a:lstStyle/>
+          <a:p>
+            <a:pPr algn="l">
+              <a:lnSpc>
+                <a:spcPct val="108000"/>
+              </a:lnSpc>
+            </a:pPr>
+            <a:r>
+              <a:rPr sz="780" b="1">
+                <a:solidFill>
+                  <a:srgbClr val="64748B"/>
+                </a:solidFill>
+                <a:latin typeface="Malgun Gothic"/>
+              </a:rPr>
+              <a:t>조회 SQL 작성</a:t>
+            </a:r>
+          </a:p>
+        </p:txBody>
+      </p:sp>
+      <p:sp>
+        <p:nvSpPr>
+          <p:cNvPr id="17" name="Oval 16"/>
           <p:cNvSpPr/>
           <p:nvPr/>
         </p:nvSpPr>
         <p:spPr>
           <a:xfrm>
-            <a:off x="6190488" y="1508760"/>
-            <a:ext cx="91440" cy="1097280"/>
-          </a:xfrm>
-          <a:prstGeom prst="rect">
+            <a:off x="8119872" y="3364991"/>
+            <a:ext cx="420624" cy="420624"/>
+          </a:xfrm>
+          <a:prstGeom prst="ellipse">
             <a:avLst/>
           </a:prstGeom>
           <a:solidFill>
@@ -16656,14 +16962,53 @@
       </p:sp>
       <p:sp>
         <p:nvSpPr>
-          <p:cNvPr id="10" name="TextBox 9"/>
-          <p:cNvSpPr txBox="1"/>
-          <p:nvPr/>
-        </p:nvSpPr>
-        <p:spPr>
-          <a:xfrm>
-            <a:off x="6446520" y="1691639"/>
-            <a:ext cx="4663440" cy="274320"/>
+          <p:cNvPr id="18" name="TextBox 17"/>
+          <p:cNvSpPr txBox="1"/>
+          <p:nvPr/>
+        </p:nvSpPr>
+        <p:spPr>
+          <a:xfrm>
+            <a:off x="8119872" y="3364991"/>
+            <a:ext cx="420624" cy="420624"/>
+          </a:xfrm>
+          <a:prstGeom prst="rect">
+            <a:avLst/>
+          </a:prstGeom>
+          <a:noFill/>
+        </p:spPr>
+        <p:txBody>
+          <a:bodyPr wrap="square" lIns="18288" rIns="18288" tIns="18288" bIns="18288" anchor="ctr">
+            <a:spAutoFit/>
+          </a:bodyPr>
+          <a:lstStyle/>
+          <a:p>
+            <a:pPr algn="ctr">
+              <a:lnSpc>
+                <a:spcPct val="108000"/>
+              </a:lnSpc>
+            </a:pPr>
+            <a:r>
+              <a:rPr sz="1300" b="1">
+                <a:solidFill>
+                  <a:srgbClr val="FFFFFF"/>
+                </a:solidFill>
+                <a:latin typeface="Malgun Gothic"/>
+              </a:rPr>
+              <a:t>3</a:t>
+            </a:r>
+          </a:p>
+        </p:txBody>
+      </p:sp>
+      <p:sp>
+        <p:nvSpPr>
+          <p:cNvPr id="19" name="TextBox 18"/>
+          <p:cNvSpPr txBox="1"/>
+          <p:nvPr/>
+        </p:nvSpPr>
+        <p:spPr>
+          <a:xfrm>
+            <a:off x="8705088" y="3383279"/>
+            <a:ext cx="1325880" cy="246888"/>
           </a:xfrm>
           <a:prstGeom prst="rect">
             <a:avLst/>
@@ -16682,27 +17027,27 @@
               </a:lnSpc>
             </a:pPr>
             <a:r>
-              <a:rPr sz="1400" b="1">
-                <a:solidFill>
-                  <a:srgbClr val="D946A3"/>
-                </a:solidFill>
-                <a:latin typeface="Malgun Gothic"/>
-              </a:rPr>
-              <a:t>실제로 달라지는 추천</a:t>
-            </a:r>
-          </a:p>
-        </p:txBody>
-      </p:sp>
-      <p:sp>
-        <p:nvSpPr>
-          <p:cNvPr id="11" name="TextBox 10"/>
-          <p:cNvSpPr txBox="1"/>
-          <p:nvPr/>
-        </p:nvSpPr>
-        <p:spPr>
-          <a:xfrm>
-            <a:off x="6446520" y="2039112"/>
-            <a:ext cx="4663440" cy="475487"/>
+              <a:rPr sz="1050" b="1">
+                <a:solidFill>
+                  <a:srgbClr val="0F172A"/>
+                </a:solidFill>
+                <a:latin typeface="Malgun Gothic"/>
+              </a:rPr>
+              <a:t>테이블 연결</a:t>
+            </a:r>
+          </a:p>
+        </p:txBody>
+      </p:sp>
+      <p:sp>
+        <p:nvSpPr>
+          <p:cNvPr id="20" name="TextBox 19"/>
+          <p:cNvSpPr txBox="1"/>
+          <p:nvPr/>
+        </p:nvSpPr>
+        <p:spPr>
+          <a:xfrm>
+            <a:off x="10012680" y="3383279"/>
+            <a:ext cx="960120" cy="365760"/>
           </a:xfrm>
           <a:prstGeom prst="rect">
             <a:avLst/>
@@ -16721,244 +17066,29 @@
               </a:lnSpc>
             </a:pPr>
             <a:r>
-              <a:rPr sz="1030" b="1">
-                <a:solidFill>
-                  <a:srgbClr val="111827"/>
-                </a:solidFill>
-                <a:latin typeface="Malgun Gothic"/>
-              </a:rPr>
-              <a:t>회원별 행동에 따라 추천 목록이 달라짐</a:t>
-            </a:r>
-          </a:p>
-        </p:txBody>
-      </p:sp>
-      <p:sp>
-        <p:nvSpPr>
-          <p:cNvPr id="12" name="Rounded Rectangle 11"/>
+              <a:rPr sz="780" b="1">
+                <a:solidFill>
+                  <a:srgbClr val="64748B"/>
+                </a:solidFill>
+                <a:latin typeface="Malgun Gothic"/>
+              </a:rPr>
+              <a:t>users + behavior_logs + products</a:t>
+            </a:r>
+          </a:p>
+        </p:txBody>
+      </p:sp>
+      <p:sp>
+        <p:nvSpPr>
+          <p:cNvPr id="21" name="Oval 20"/>
           <p:cNvSpPr/>
           <p:nvPr/>
         </p:nvSpPr>
         <p:spPr>
           <a:xfrm>
-            <a:off x="658368" y="2862072"/>
-            <a:ext cx="5166360" cy="1097280"/>
-          </a:xfrm>
-          <a:prstGeom prst="roundRect">
-            <a:avLst>
-              <a:gd name="adj" fmla="val 12000"/>
-            </a:avLst>
-          </a:prstGeom>
-          <a:solidFill>
-            <a:srgbClr val="FFFFFF"/>
-          </a:solidFill>
-          <a:ln w="12700">
-            <a:solidFill>
-              <a:srgbClr val="D9DEEA"/>
-            </a:solidFill>
-          </a:ln>
-        </p:spPr>
-        <p:style>
-          <a:lnRef idx="1">
-            <a:schemeClr val="accent1"/>
-          </a:lnRef>
-          <a:fillRef idx="3">
-            <a:schemeClr val="accent1"/>
-          </a:fillRef>
-          <a:effectRef idx="2">
-            <a:schemeClr val="accent1"/>
-          </a:effectRef>
-          <a:fontRef idx="minor">
-            <a:schemeClr val="lt1"/>
-          </a:fontRef>
-        </p:style>
-        <p:txBody>
-          <a:bodyPr rtlCol="0" anchor="ctr"/>
-          <a:lstStyle/>
-          <a:p>
-            <a:pPr algn="ctr"/>
-          </a:p>
-        </p:txBody>
-      </p:sp>
-      <p:sp>
-        <p:nvSpPr>
-          <p:cNvPr id="13" name="Rectangle 12"/>
-          <p:cNvSpPr/>
-          <p:nvPr/>
-        </p:nvSpPr>
-        <p:spPr>
-          <a:xfrm>
-            <a:off x="658368" y="2862072"/>
-            <a:ext cx="91440" cy="1097280"/>
-          </a:xfrm>
-          <a:prstGeom prst="rect">
-            <a:avLst/>
-          </a:prstGeom>
-          <a:solidFill>
-            <a:srgbClr val="2563EB"/>
-          </a:solidFill>
-          <a:ln>
-            <a:noFill/>
-          </a:ln>
-        </p:spPr>
-        <p:style>
-          <a:lnRef idx="1">
-            <a:schemeClr val="accent1"/>
-          </a:lnRef>
-          <a:fillRef idx="3">
-            <a:schemeClr val="accent1"/>
-          </a:fillRef>
-          <a:effectRef idx="2">
-            <a:schemeClr val="accent1"/>
-          </a:effectRef>
-          <a:fontRef idx="minor">
-            <a:schemeClr val="lt1"/>
-          </a:fontRef>
-        </p:style>
-        <p:txBody>
-          <a:bodyPr rtlCol="0" anchor="ctr"/>
-          <a:lstStyle/>
-          <a:p>
-            <a:pPr algn="ctr"/>
-          </a:p>
-        </p:txBody>
-      </p:sp>
-      <p:sp>
-        <p:nvSpPr>
-          <p:cNvPr id="14" name="TextBox 13"/>
-          <p:cNvSpPr txBox="1"/>
-          <p:nvPr/>
-        </p:nvSpPr>
-        <p:spPr>
-          <a:xfrm>
-            <a:off x="914400" y="3044952"/>
-            <a:ext cx="4663440" cy="274320"/>
-          </a:xfrm>
-          <a:prstGeom prst="rect">
-            <a:avLst/>
-          </a:prstGeom>
-          <a:noFill/>
-        </p:spPr>
-        <p:txBody>
-          <a:bodyPr wrap="square" lIns="18288" rIns="18288" tIns="18288" bIns="18288" anchor="t">
-            <a:spAutoFit/>
-          </a:bodyPr>
-          <a:lstStyle/>
-          <a:p>
-            <a:pPr algn="l">
-              <a:lnSpc>
-                <a:spcPct val="108000"/>
-              </a:lnSpc>
-            </a:pPr>
-            <a:r>
-              <a:rPr sz="1400" b="1">
-                <a:solidFill>
-                  <a:srgbClr val="2563EB"/>
-                </a:solidFill>
-                <a:latin typeface="Malgun Gothic"/>
-              </a:rPr>
-              <a:t>빠르고 가벼운 AI</a:t>
-            </a:r>
-          </a:p>
-        </p:txBody>
-      </p:sp>
-      <p:sp>
-        <p:nvSpPr>
-          <p:cNvPr id="15" name="TextBox 14"/>
-          <p:cNvSpPr txBox="1"/>
-          <p:nvPr/>
-        </p:nvSpPr>
-        <p:spPr>
-          <a:xfrm>
-            <a:off x="914400" y="3392424"/>
-            <a:ext cx="4663440" cy="475487"/>
-          </a:xfrm>
-          <a:prstGeom prst="rect">
-            <a:avLst/>
-          </a:prstGeom>
-          <a:noFill/>
-        </p:spPr>
-        <p:txBody>
-          <a:bodyPr wrap="square" lIns="18288" rIns="18288" tIns="18288" bIns="18288" anchor="t">
-            <a:spAutoFit/>
-          </a:bodyPr>
-          <a:lstStyle/>
-          <a:p>
-            <a:pPr algn="l">
-              <a:lnSpc>
-                <a:spcPct val="108000"/>
-              </a:lnSpc>
-            </a:pPr>
-            <a:r>
-              <a:rPr sz="1030" b="1">
-                <a:solidFill>
-                  <a:srgbClr val="111827"/>
-                </a:solidFill>
-                <a:latin typeface="Malgun Gothic"/>
-              </a:rPr>
-              <a:t>작은 TextCNN 모델을 평균 0.0127초에 실행</a:t>
-            </a:r>
-          </a:p>
-        </p:txBody>
-      </p:sp>
-      <p:sp>
-        <p:nvSpPr>
-          <p:cNvPr id="16" name="Rounded Rectangle 15"/>
-          <p:cNvSpPr/>
-          <p:nvPr/>
-        </p:nvSpPr>
-        <p:spPr>
-          <a:xfrm>
-            <a:off x="6190488" y="2862072"/>
-            <a:ext cx="5166360" cy="1097280"/>
-          </a:xfrm>
-          <a:prstGeom prst="roundRect">
-            <a:avLst>
-              <a:gd name="adj" fmla="val 12000"/>
-            </a:avLst>
-          </a:prstGeom>
-          <a:solidFill>
-            <a:srgbClr val="FFFFFF"/>
-          </a:solidFill>
-          <a:ln w="12700">
-            <a:solidFill>
-              <a:srgbClr val="D9DEEA"/>
-            </a:solidFill>
-          </a:ln>
-        </p:spPr>
-        <p:style>
-          <a:lnRef idx="1">
-            <a:schemeClr val="accent1"/>
-          </a:lnRef>
-          <a:fillRef idx="3">
-            <a:schemeClr val="accent1"/>
-          </a:fillRef>
-          <a:effectRef idx="2">
-            <a:schemeClr val="accent1"/>
-          </a:effectRef>
-          <a:fontRef idx="minor">
-            <a:schemeClr val="lt1"/>
-          </a:fontRef>
-        </p:style>
-        <p:txBody>
-          <a:bodyPr rtlCol="0" anchor="ctr"/>
-          <a:lstStyle/>
-          <a:p>
-            <a:pPr algn="ctr"/>
-          </a:p>
-        </p:txBody>
-      </p:sp>
-      <p:sp>
-        <p:nvSpPr>
-          <p:cNvPr id="17" name="Rectangle 16"/>
-          <p:cNvSpPr/>
-          <p:nvPr/>
-        </p:nvSpPr>
-        <p:spPr>
-          <a:xfrm>
-            <a:off x="6190488" y="2862072"/>
-            <a:ext cx="91440" cy="1097280"/>
-          </a:xfrm>
-          <a:prstGeom prst="rect">
+            <a:off x="8119872" y="3959352"/>
+            <a:ext cx="420624" cy="420624"/>
+          </a:xfrm>
+          <a:prstGeom prst="ellipse">
             <a:avLst/>
           </a:prstGeom>
           <a:solidFill>
@@ -16992,14 +17122,53 @@
       </p:sp>
       <p:sp>
         <p:nvSpPr>
-          <p:cNvPr id="18" name="TextBox 17"/>
-          <p:cNvSpPr txBox="1"/>
-          <p:nvPr/>
-        </p:nvSpPr>
-        <p:spPr>
-          <a:xfrm>
-            <a:off x="6446520" y="3044952"/>
-            <a:ext cx="4663440" cy="274320"/>
+          <p:cNvPr id="22" name="TextBox 21"/>
+          <p:cNvSpPr txBox="1"/>
+          <p:nvPr/>
+        </p:nvSpPr>
+        <p:spPr>
+          <a:xfrm>
+            <a:off x="8119872" y="3959352"/>
+            <a:ext cx="420624" cy="420624"/>
+          </a:xfrm>
+          <a:prstGeom prst="rect">
+            <a:avLst/>
+          </a:prstGeom>
+          <a:noFill/>
+        </p:spPr>
+        <p:txBody>
+          <a:bodyPr wrap="square" lIns="18288" rIns="18288" tIns="18288" bIns="18288" anchor="ctr">
+            <a:spAutoFit/>
+          </a:bodyPr>
+          <a:lstStyle/>
+          <a:p>
+            <a:pPr algn="ctr">
+              <a:lnSpc>
+                <a:spcPct val="108000"/>
+              </a:lnSpc>
+            </a:pPr>
+            <a:r>
+              <a:rPr sz="1300" b="1">
+                <a:solidFill>
+                  <a:srgbClr val="FFFFFF"/>
+                </a:solidFill>
+                <a:latin typeface="Malgun Gothic"/>
+              </a:rPr>
+              <a:t>4</a:t>
+            </a:r>
+          </a:p>
+        </p:txBody>
+      </p:sp>
+      <p:sp>
+        <p:nvSpPr>
+          <p:cNvPr id="23" name="TextBox 22"/>
+          <p:cNvSpPr txBox="1"/>
+          <p:nvPr/>
+        </p:nvSpPr>
+        <p:spPr>
+          <a:xfrm>
+            <a:off x="8705088" y="3977639"/>
+            <a:ext cx="1325880" cy="246888"/>
           </a:xfrm>
           <a:prstGeom prst="rect">
             <a:avLst/>
@@ -17018,27 +17187,27 @@
               </a:lnSpc>
             </a:pPr>
             <a:r>
-              <a:rPr sz="1400" b="1">
-                <a:solidFill>
-                  <a:srgbClr val="16A34A"/>
-                </a:solidFill>
-                <a:latin typeface="Malgun Gothic"/>
-              </a:rPr>
-              <a:t>관리 가능한 데이터</a:t>
-            </a:r>
-          </a:p>
-        </p:txBody>
-      </p:sp>
-      <p:sp>
-        <p:nvSpPr>
-          <p:cNvPr id="19" name="TextBox 18"/>
-          <p:cNvSpPr txBox="1"/>
-          <p:nvPr/>
-        </p:nvSpPr>
-        <p:spPr>
-          <a:xfrm>
-            <a:off x="6446520" y="3392424"/>
-            <a:ext cx="4663440" cy="475487"/>
+              <a:rPr sz="1050" b="1">
+                <a:solidFill>
+                  <a:srgbClr val="0F172A"/>
+                </a:solidFill>
+                <a:latin typeface="Malgun Gothic"/>
+              </a:rPr>
+              <a:t>결과 확인</a:t>
+            </a:r>
+          </a:p>
+        </p:txBody>
+      </p:sp>
+      <p:sp>
+        <p:nvSpPr>
+          <p:cNvPr id="24" name="TextBox 23"/>
+          <p:cNvSpPr txBox="1"/>
+          <p:nvPr/>
+        </p:nvSpPr>
+        <p:spPr>
+          <a:xfrm>
+            <a:off x="10012680" y="3977639"/>
+            <a:ext cx="960120" cy="365760"/>
           </a:xfrm>
           <a:prstGeom prst="rect">
             <a:avLst/>
@@ -17057,27 +17226,151 @@
               </a:lnSpc>
             </a:pPr>
             <a:r>
-              <a:rPr sz="1030" b="1">
-                <a:solidFill>
-                  <a:srgbClr val="111827"/>
-                </a:solidFill>
-                <a:latin typeface="Malgun Gothic"/>
-              </a:rPr>
-              <a:t>MySQL과 DBeaver로 회원·행동·주문 확인</a:t>
-            </a:r>
-          </a:p>
-        </p:txBody>
-      </p:sp>
-      <p:sp>
-        <p:nvSpPr>
-          <p:cNvPr id="20" name="Rounded Rectangle 19"/>
+              <a:rPr sz="780" b="1">
+                <a:solidFill>
+                  <a:srgbClr val="64748B"/>
+                </a:solidFill>
+                <a:latin typeface="Malgun Gothic"/>
+              </a:rPr>
+              <a:t>회원별 행동 78행 조회</a:t>
+            </a:r>
+          </a:p>
+        </p:txBody>
+      </p:sp>
+      <p:sp>
+        <p:nvSpPr>
+          <p:cNvPr id="25" name="Rounded Rectangle 24"/>
           <p:cNvSpPr/>
           <p:nvPr/>
         </p:nvSpPr>
         <p:spPr>
           <a:xfrm>
-            <a:off x="658368" y="4498848"/>
-            <a:ext cx="10698480" cy="566928"/>
+            <a:off x="8110727" y="4379976"/>
+            <a:ext cx="2907792" cy="438912"/>
+          </a:xfrm>
+          <a:prstGeom prst="roundRect">
+            <a:avLst>
+              <a:gd name="adj" fmla="val 12000"/>
+            </a:avLst>
+          </a:prstGeom>
+          <a:solidFill>
+            <a:srgbClr val="DFF7E9"/>
+          </a:solidFill>
+          <a:ln>
+            <a:noFill/>
+          </a:ln>
+        </p:spPr>
+        <p:style>
+          <a:lnRef idx="1">
+            <a:schemeClr val="accent1"/>
+          </a:lnRef>
+          <a:fillRef idx="3">
+            <a:schemeClr val="accent1"/>
+          </a:fillRef>
+          <a:effectRef idx="2">
+            <a:schemeClr val="accent1"/>
+          </a:effectRef>
+          <a:fontRef idx="minor">
+            <a:schemeClr val="lt1"/>
+          </a:fontRef>
+        </p:style>
+        <p:txBody>
+          <a:bodyPr rtlCol="0" anchor="ctr"/>
+          <a:lstStyle/>
+          <a:p>
+            <a:pPr algn="ctr"/>
+          </a:p>
+        </p:txBody>
+      </p:sp>
+      <p:sp>
+        <p:nvSpPr>
+          <p:cNvPr id="26" name="TextBox 25"/>
+          <p:cNvSpPr txBox="1"/>
+          <p:nvPr/>
+        </p:nvSpPr>
+        <p:spPr>
+          <a:xfrm>
+            <a:off x="8229600" y="4425696"/>
+            <a:ext cx="2670048" cy="329184"/>
+          </a:xfrm>
+          <a:prstGeom prst="rect">
+            <a:avLst/>
+          </a:prstGeom>
+          <a:noFill/>
+        </p:spPr>
+        <p:txBody>
+          <a:bodyPr wrap="square" lIns="18288" rIns="18288" tIns="18288" bIns="18288" anchor="t">
+            <a:spAutoFit/>
+          </a:bodyPr>
+          <a:lstStyle/>
+          <a:p>
+            <a:pPr algn="ctr">
+              <a:lnSpc>
+                <a:spcPct val="108000"/>
+              </a:lnSpc>
+            </a:pPr>
+            <a:r>
+              <a:rPr sz="640" b="1">
+                <a:solidFill>
+                  <a:srgbClr val="166534"/>
+                </a:solidFill>
+                <a:latin typeface="Malgun Gothic"/>
+              </a:rPr>
+              <a:t>VIEW 조회 · CART_ADD 담기 · WISHLIST_ADD 찜
+PURCHASE 구매 · PURCHASE_CANCEL 취소</a:t>
+            </a:r>
+          </a:p>
+        </p:txBody>
+      </p:sp>
+      <p:sp>
+        <p:nvSpPr>
+          <p:cNvPr id="27" name="TextBox 26"/>
+          <p:cNvSpPr txBox="1"/>
+          <p:nvPr/>
+        </p:nvSpPr>
+        <p:spPr>
+          <a:xfrm>
+            <a:off x="8183879" y="4855464"/>
+            <a:ext cx="2743200" cy="164592"/>
+          </a:xfrm>
+          <a:prstGeom prst="rect">
+            <a:avLst/>
+          </a:prstGeom>
+          <a:noFill/>
+        </p:spPr>
+        <p:txBody>
+          <a:bodyPr wrap="square" lIns="18288" rIns="18288" tIns="18288" bIns="18288" anchor="t">
+            <a:spAutoFit/>
+          </a:bodyPr>
+          <a:lstStyle/>
+          <a:p>
+            <a:pPr algn="ctr">
+              <a:lnSpc>
+                <a:spcPct val="108000"/>
+              </a:lnSpc>
+            </a:pPr>
+            <a:r>
+              <a:rPr sz="670" b="1">
+                <a:solidFill>
+                  <a:srgbClr val="64748B"/>
+                </a:solidFill>
+                <a:latin typeface="Malgun Gothic"/>
+              </a:rPr>
+              <a:t>78행 · 이메일·닉네임·상품·세션·시각 함께 조회</a:t>
+            </a:r>
+          </a:p>
+        </p:txBody>
+      </p:sp>
+      <p:sp>
+        <p:nvSpPr>
+          <p:cNvPr id="28" name="Rounded Rectangle 27"/>
+          <p:cNvSpPr/>
+          <p:nvPr/>
+        </p:nvSpPr>
+        <p:spPr>
+          <a:xfrm>
+            <a:off x="658368" y="5532120"/>
+            <a:ext cx="10881360" cy="749808"/>
           </a:xfrm>
           <a:prstGeom prst="roundRect">
             <a:avLst>
@@ -17115,91 +17408,7 @@
       </p:sp>
       <p:sp>
         <p:nvSpPr>
-          <p:cNvPr id="21" name="TextBox 20"/>
-          <p:cNvSpPr txBox="1"/>
-          <p:nvPr/>
-        </p:nvSpPr>
-        <p:spPr>
-          <a:xfrm>
-            <a:off x="914400" y="4645152"/>
-            <a:ext cx="10149840" cy="274320"/>
-          </a:xfrm>
-          <a:prstGeom prst="rect">
-            <a:avLst/>
-          </a:prstGeom>
-          <a:noFill/>
-        </p:spPr>
-        <p:txBody>
-          <a:bodyPr wrap="square" lIns="18288" rIns="18288" tIns="18288" bIns="18288" anchor="t">
-            <a:spAutoFit/>
-          </a:bodyPr>
-          <a:lstStyle/>
-          <a:p>
-            <a:pPr algn="ctr">
-              <a:lnSpc>
-                <a:spcPct val="108000"/>
-              </a:lnSpc>
-            </a:pPr>
-            <a:r>
-              <a:rPr sz="1080" b="1">
-                <a:solidFill>
-                  <a:srgbClr val="FFFFFF"/>
-                </a:solidFill>
-                <a:latin typeface="Malgun Gothic"/>
-              </a:rPr>
-              <a:t>현재는 포트폴리오용 모의 쇼핑몰이며, 실제 결제·배송·대규모 사용자 데이터는 향후 확장 영역입니다.</a:t>
-            </a:r>
-          </a:p>
-        </p:txBody>
-      </p:sp>
-      <p:sp>
-        <p:nvSpPr>
-          <p:cNvPr id="22" name="Rounded Rectangle 21"/>
-          <p:cNvSpPr/>
-          <p:nvPr/>
-        </p:nvSpPr>
-        <p:spPr>
-          <a:xfrm>
-            <a:off x="658368" y="5532120"/>
-            <a:ext cx="10881360" cy="749808"/>
-          </a:xfrm>
-          <a:prstGeom prst="roundRect">
-            <a:avLst>
-              <a:gd name="adj" fmla="val 12000"/>
-            </a:avLst>
-          </a:prstGeom>
-          <a:solidFill>
-            <a:srgbClr val="0F172A"/>
-          </a:solidFill>
-          <a:ln>
-            <a:noFill/>
-          </a:ln>
-        </p:spPr>
-        <p:style>
-          <a:lnRef idx="1">
-            <a:schemeClr val="accent1"/>
-          </a:lnRef>
-          <a:fillRef idx="3">
-            <a:schemeClr val="accent1"/>
-          </a:fillRef>
-          <a:effectRef idx="2">
-            <a:schemeClr val="accent1"/>
-          </a:effectRef>
-          <a:fontRef idx="minor">
-            <a:schemeClr val="lt1"/>
-          </a:fontRef>
-        </p:style>
-        <p:txBody>
-          <a:bodyPr rtlCol="0" anchor="ctr"/>
-          <a:lstStyle/>
-          <a:p>
-            <a:pPr algn="ctr"/>
-          </a:p>
-        </p:txBody>
-      </p:sp>
-      <p:sp>
-        <p:nvSpPr>
-          <p:cNvPr id="23" name="TextBox 22"/>
+          <p:cNvPr id="29" name="TextBox 28"/>
           <p:cNvSpPr txBox="1"/>
           <p:nvPr/>
         </p:nvSpPr>
@@ -17238,7 +17447,7 @@
       </p:sp>
       <p:sp>
         <p:nvSpPr>
-          <p:cNvPr id="24" name="TextBox 23"/>
+          <p:cNvPr id="30" name="TextBox 29"/>
           <p:cNvSpPr txBox="1"/>
           <p:nvPr/>
         </p:nvSpPr>
@@ -17270,14 +17479,14 @@
                 </a:solidFill>
                 <a:latin typeface="Malgun Gothic"/>
               </a:rPr>
-              <a:t>이 프로젝트에서 가장 중요한 결과는 AI 모델만 만든 것이 아니라 추천이 실제 쇼핑 과정으로 이어지는 서비스를 완성했다는 점입니다. 현재는 포트폴리오용 모의 결제 서비스이며, 앞으로 실제 사용자 로그와 결제·배송 기능을 연결할 수 있습니다.</a:t>
-            </a:r>
-          </a:p>
-        </p:txBody>
-      </p:sp>
-      <p:sp>
-        <p:nvSpPr>
-          <p:cNvPr id="25" name="TextBox 24"/>
+              <a:t>Aiven MySQL은 DBeaver로 직접 확인할 수 있습니다. users, behavior_logs, products를 연결한 SQL 결과로 이메일·닉네임·행동·상품·세션·시각 78행을 확인했습니다. VIEW는 조회, CART_ADD는 담기, PURCHASE는 구매를 뜻하며 운영 DB에서는 조회 중심으로 관리합니다.</a:t>
+            </a:r>
+          </a:p>
+        </p:txBody>
+      </p:sp>
+      <p:sp>
+        <p:nvSpPr>
+          <p:cNvPr id="31" name="TextBox 30"/>
           <p:cNvSpPr txBox="1"/>
           <p:nvPr/>
         </p:nvSpPr>
@@ -17328,7 +17537,7 @@
     <p:bg>
       <p:bgPr>
         <a:solidFill>
-          <a:srgbClr val="0F172A"/>
+          <a:srgbClr val="F5F7FF"/>
         </a:solidFill>
         <a:effectLst/>
       </p:bgPr>
@@ -17374,7 +17583,7 @@
                 </a:solidFill>
                 <a:latin typeface="Malgun Gothic"/>
               </a:rPr>
-              <a:t>18 · 발표 마무리</a:t>
+              <a:t>18 · 결론</a:t>
             </a:r>
           </a:p>
         </p:txBody>
@@ -17409,64 +17618,25 @@
             <a:r>
               <a:rPr sz="2700" b="1">
                 <a:solidFill>
-                  <a:srgbClr val="FFFFFF"/>
-                </a:solidFill>
-                <a:latin typeface="Malgun Gothic"/>
-              </a:rPr>
-              <a:t>라이브 시연은 이 순서로 진행</a:t>
-            </a:r>
-          </a:p>
-        </p:txBody>
-      </p:sp>
-      <p:sp>
-        <p:nvSpPr>
-          <p:cNvPr id="4" name="TextBox 3"/>
-          <p:cNvSpPr txBox="1"/>
-          <p:nvPr/>
-        </p:nvSpPr>
-        <p:spPr>
-          <a:xfrm>
-            <a:off x="685800" y="1399032"/>
-            <a:ext cx="10607040" cy="420624"/>
-          </a:xfrm>
-          <a:prstGeom prst="rect">
-            <a:avLst/>
-          </a:prstGeom>
-          <a:noFill/>
-        </p:spPr>
-        <p:txBody>
-          <a:bodyPr wrap="square" lIns="18288" rIns="18288" tIns="18288" bIns="18288" anchor="t">
-            <a:spAutoFit/>
-          </a:bodyPr>
-          <a:lstStyle/>
-          <a:p>
-            <a:pPr algn="l">
-              <a:lnSpc>
-                <a:spcPct val="108000"/>
-              </a:lnSpc>
-            </a:pPr>
-            <a:r>
-              <a:rPr sz="1300" b="0">
-                <a:solidFill>
-                  <a:srgbClr val="CBD5E1"/>
-                </a:solidFill>
-                <a:latin typeface="Malgun Gothic"/>
-              </a:rPr>
-              <a:t>기능을 모두 보여주기보다 개인화가 달라지는 핵심 흐름에 집중합니다.</a:t>
-            </a:r>
-          </a:p>
-        </p:txBody>
-      </p:sp>
-      <p:sp>
-        <p:nvSpPr>
-          <p:cNvPr id="5" name="Rounded Rectangle 4"/>
+                  <a:srgbClr val="0F172A"/>
+                </a:solidFill>
+                <a:latin typeface="Malgun Gothic"/>
+              </a:rPr>
+              <a:t>이 프로젝트를 통해 완성한 것</a:t>
+            </a:r>
+          </a:p>
+        </p:txBody>
+      </p:sp>
+      <p:sp>
+        <p:nvSpPr>
+          <p:cNvPr id="4" name="Rounded Rectangle 3"/>
           <p:cNvSpPr/>
           <p:nvPr/>
         </p:nvSpPr>
         <p:spPr>
           <a:xfrm>
-            <a:off x="530352" y="1828800"/>
-            <a:ext cx="1947672" cy="2057400"/>
+            <a:off x="658368" y="1508760"/>
+            <a:ext cx="5166360" cy="1097280"/>
           </a:xfrm>
           <a:prstGeom prst="roundRect">
             <a:avLst>
@@ -17474,11 +17644,11 @@
             </a:avLst>
           </a:prstGeom>
           <a:solidFill>
-            <a:srgbClr val="182235"/>
+            <a:srgbClr val="FFFFFF"/>
           </a:solidFill>
           <a:ln w="12700">
             <a:solidFill>
-              <a:srgbClr val="334155"/>
+              <a:srgbClr val="D9DEEA"/>
             </a:solidFill>
           </a:ln>
         </p:spPr>
@@ -17506,16 +17676,16 @@
       </p:sp>
       <p:sp>
         <p:nvSpPr>
-          <p:cNvPr id="6" name="Oval 5"/>
+          <p:cNvPr id="5" name="Rectangle 4"/>
           <p:cNvSpPr/>
           <p:nvPr/>
         </p:nvSpPr>
         <p:spPr>
           <a:xfrm>
-            <a:off x="1280160" y="2084831"/>
-            <a:ext cx="420624" cy="420624"/>
-          </a:xfrm>
-          <a:prstGeom prst="ellipse">
+            <a:off x="658368" y="1508760"/>
+            <a:ext cx="91440" cy="1097280"/>
+          </a:xfrm>
+          <a:prstGeom prst="rect">
             <a:avLst/>
           </a:prstGeom>
           <a:solidFill>
@@ -17549,166 +17719,92 @@
       </p:sp>
       <p:sp>
         <p:nvSpPr>
+          <p:cNvPr id="6" name="TextBox 5"/>
+          <p:cNvSpPr txBox="1"/>
+          <p:nvPr/>
+        </p:nvSpPr>
+        <p:spPr>
+          <a:xfrm>
+            <a:off x="914400" y="1691639"/>
+            <a:ext cx="4663440" cy="274320"/>
+          </a:xfrm>
+          <a:prstGeom prst="rect">
+            <a:avLst/>
+          </a:prstGeom>
+          <a:noFill/>
+        </p:spPr>
+        <p:txBody>
+          <a:bodyPr wrap="square" lIns="18288" rIns="18288" tIns="18288" bIns="18288" anchor="t">
+            <a:spAutoFit/>
+          </a:bodyPr>
+          <a:lstStyle/>
+          <a:p>
+            <a:pPr algn="l">
+              <a:lnSpc>
+                <a:spcPct val="108000"/>
+              </a:lnSpc>
+            </a:pPr>
+            <a:r>
+              <a:rPr sz="1400" b="1">
+                <a:solidFill>
+                  <a:srgbClr val="6246EA"/>
+                </a:solidFill>
+                <a:latin typeface="Malgun Gothic"/>
+              </a:rPr>
+              <a:t>하나의 완성된 서비스</a:t>
+            </a:r>
+          </a:p>
+        </p:txBody>
+      </p:sp>
+      <p:sp>
+        <p:nvSpPr>
           <p:cNvPr id="7" name="TextBox 6"/>
           <p:cNvSpPr txBox="1"/>
           <p:nvPr/>
         </p:nvSpPr>
         <p:spPr>
           <a:xfrm>
-            <a:off x="1280160" y="2084831"/>
-            <a:ext cx="420624" cy="420624"/>
-          </a:xfrm>
-          <a:prstGeom prst="rect">
-            <a:avLst/>
-          </a:prstGeom>
-          <a:noFill/>
-        </p:spPr>
-        <p:txBody>
-          <a:bodyPr wrap="square" lIns="18288" rIns="18288" tIns="18288" bIns="18288" anchor="ctr">
-            <a:spAutoFit/>
-          </a:bodyPr>
-          <a:lstStyle/>
-          <a:p>
-            <a:pPr algn="ctr">
-              <a:lnSpc>
-                <a:spcPct val="108000"/>
-              </a:lnSpc>
-            </a:pPr>
-            <a:r>
-              <a:rPr sz="1300" b="1">
-                <a:solidFill>
-                  <a:srgbClr val="FFFFFF"/>
-                </a:solidFill>
-                <a:latin typeface="Malgun Gothic"/>
-              </a:rPr>
-              <a:t>1</a:t>
-            </a:r>
-          </a:p>
-        </p:txBody>
-      </p:sp>
-      <p:sp>
-        <p:nvSpPr>
-          <p:cNvPr id="8" name="TextBox 7"/>
-          <p:cNvSpPr txBox="1"/>
-          <p:nvPr/>
-        </p:nvSpPr>
-        <p:spPr>
-          <a:xfrm>
-            <a:off x="713232" y="2743200"/>
-            <a:ext cx="1581912" cy="274320"/>
-          </a:xfrm>
-          <a:prstGeom prst="rect">
-            <a:avLst/>
-          </a:prstGeom>
-          <a:noFill/>
-        </p:spPr>
-        <p:txBody>
-          <a:bodyPr wrap="square" lIns="18288" rIns="18288" tIns="18288" bIns="18288" anchor="t">
-            <a:spAutoFit/>
-          </a:bodyPr>
-          <a:lstStyle/>
-          <a:p>
-            <a:pPr algn="ctr">
-              <a:lnSpc>
-                <a:spcPct val="108000"/>
-              </a:lnSpc>
-            </a:pPr>
-            <a:r>
-              <a:rPr sz="1300" b="1">
-                <a:solidFill>
-                  <a:srgbClr val="FFFFFF"/>
-                </a:solidFill>
-                <a:latin typeface="Malgun Gothic"/>
-              </a:rPr>
-              <a:t>로그인</a:t>
-            </a:r>
-          </a:p>
-        </p:txBody>
-      </p:sp>
-      <p:sp>
-        <p:nvSpPr>
-          <p:cNvPr id="9" name="TextBox 8"/>
-          <p:cNvSpPr txBox="1"/>
-          <p:nvPr/>
-        </p:nvSpPr>
-        <p:spPr>
-          <a:xfrm>
-            <a:off x="713232" y="3182112"/>
-            <a:ext cx="1581912" cy="347472"/>
-          </a:xfrm>
-          <a:prstGeom prst="rect">
-            <a:avLst/>
-          </a:prstGeom>
-          <a:noFill/>
-        </p:spPr>
-        <p:txBody>
-          <a:bodyPr wrap="square" lIns="18288" rIns="18288" tIns="18288" bIns="18288" anchor="t">
-            <a:spAutoFit/>
-          </a:bodyPr>
-          <a:lstStyle/>
-          <a:p>
-            <a:pPr algn="ctr">
-              <a:lnSpc>
-                <a:spcPct val="108000"/>
-              </a:lnSpc>
-            </a:pPr>
-            <a:r>
-              <a:rPr sz="919" b="0">
-                <a:solidFill>
-                  <a:srgbClr val="CBD5E1"/>
-                </a:solidFill>
-                <a:latin typeface="Malgun Gothic"/>
-              </a:rPr>
-              <a:t>회원 계정으로 접속</a:t>
-            </a:r>
-          </a:p>
-        </p:txBody>
-      </p:sp>
-      <p:cxnSp>
-        <p:nvCxnSpPr>
-          <p:cNvPr id="10" name="Connector 9"/>
-          <p:cNvCxnSpPr/>
-          <p:nvPr/>
-        </p:nvCxnSpPr>
-        <p:spPr>
-          <a:xfrm>
-            <a:off x="2478024" y="2871216"/>
-            <a:ext cx="310896" cy="0"/>
-          </a:xfrm>
-          <a:prstGeom prst="line">
-            <a:avLst/>
-          </a:prstGeom>
-          <a:ln w="25400">
-            <a:solidFill>
-              <a:srgbClr val="A78BFA"/>
-            </a:solidFill>
-          </a:ln>
-        </p:spPr>
-        <p:style>
-          <a:lnRef idx="2">
-            <a:schemeClr val="accent1"/>
-          </a:lnRef>
-          <a:fillRef idx="0">
-            <a:schemeClr val="accent1"/>
-          </a:fillRef>
-          <a:effectRef idx="1">
-            <a:schemeClr val="accent1"/>
-          </a:effectRef>
-          <a:fontRef idx="minor">
-            <a:schemeClr val="tx1"/>
-          </a:fontRef>
-        </p:style>
-      </p:cxnSp>
-      <p:sp>
-        <p:nvSpPr>
-          <p:cNvPr id="11" name="Rounded Rectangle 10"/>
+            <a:off x="914400" y="2039112"/>
+            <a:ext cx="4663440" cy="475487"/>
+          </a:xfrm>
+          <a:prstGeom prst="rect">
+            <a:avLst/>
+          </a:prstGeom>
+          <a:noFill/>
+        </p:spPr>
+        <p:txBody>
+          <a:bodyPr wrap="square" lIns="18288" rIns="18288" tIns="18288" bIns="18288" anchor="t">
+            <a:spAutoFit/>
+          </a:bodyPr>
+          <a:lstStyle/>
+          <a:p>
+            <a:pPr algn="l">
+              <a:lnSpc>
+                <a:spcPct val="108000"/>
+              </a:lnSpc>
+            </a:pPr>
+            <a:r>
+              <a:rPr sz="1030" b="1">
+                <a:solidFill>
+                  <a:srgbClr val="111827"/>
+                </a:solidFill>
+                <a:latin typeface="Malgun Gothic"/>
+              </a:rPr>
+              <a:t>로그인부터 추천·주문·취소·후기까지 연결</a:t>
+            </a:r>
+          </a:p>
+        </p:txBody>
+      </p:sp>
+      <p:sp>
+        <p:nvSpPr>
+          <p:cNvPr id="8" name="Rounded Rectangle 7"/>
           <p:cNvSpPr/>
           <p:nvPr/>
         </p:nvSpPr>
         <p:spPr>
           <a:xfrm>
-            <a:off x="2871216" y="1828800"/>
-            <a:ext cx="1947672" cy="2057400"/>
+            <a:off x="6190488" y="1508760"/>
+            <a:ext cx="5166360" cy="1097280"/>
           </a:xfrm>
           <a:prstGeom prst="roundRect">
             <a:avLst>
@@ -17716,11 +17812,11 @@
             </a:avLst>
           </a:prstGeom>
           <a:solidFill>
-            <a:srgbClr val="182235"/>
+            <a:srgbClr val="FFFFFF"/>
           </a:solidFill>
           <a:ln w="12700">
             <a:solidFill>
-              <a:srgbClr val="334155"/>
+              <a:srgbClr val="D9DEEA"/>
             </a:solidFill>
           </a:ln>
         </p:spPr>
@@ -17748,20 +17844,20 @@
       </p:sp>
       <p:sp>
         <p:nvSpPr>
-          <p:cNvPr id="12" name="Oval 11"/>
+          <p:cNvPr id="9" name="Rectangle 8"/>
           <p:cNvSpPr/>
           <p:nvPr/>
         </p:nvSpPr>
         <p:spPr>
           <a:xfrm>
-            <a:off x="3621024" y="2084831"/>
-            <a:ext cx="420624" cy="420624"/>
-          </a:xfrm>
-          <a:prstGeom prst="ellipse">
+            <a:off x="6190488" y="1508760"/>
+            <a:ext cx="91440" cy="1097280"/>
+          </a:xfrm>
+          <a:prstGeom prst="rect">
             <a:avLst/>
           </a:prstGeom>
           <a:solidFill>
-            <a:srgbClr val="8B5CF6"/>
+            <a:srgbClr val="D946A3"/>
           </a:solidFill>
           <a:ln>
             <a:noFill/>
@@ -17791,166 +17887,92 @@
       </p:sp>
       <p:sp>
         <p:nvSpPr>
-          <p:cNvPr id="13" name="TextBox 12"/>
-          <p:cNvSpPr txBox="1"/>
-          <p:nvPr/>
-        </p:nvSpPr>
-        <p:spPr>
-          <a:xfrm>
-            <a:off x="3621024" y="2084831"/>
-            <a:ext cx="420624" cy="420624"/>
-          </a:xfrm>
-          <a:prstGeom prst="rect">
-            <a:avLst/>
-          </a:prstGeom>
-          <a:noFill/>
-        </p:spPr>
-        <p:txBody>
-          <a:bodyPr wrap="square" lIns="18288" rIns="18288" tIns="18288" bIns="18288" anchor="ctr">
-            <a:spAutoFit/>
-          </a:bodyPr>
-          <a:lstStyle/>
-          <a:p>
-            <a:pPr algn="ctr">
-              <a:lnSpc>
-                <a:spcPct val="108000"/>
-              </a:lnSpc>
-            </a:pPr>
-            <a:r>
-              <a:rPr sz="1300" b="1">
-                <a:solidFill>
-                  <a:srgbClr val="FFFFFF"/>
-                </a:solidFill>
-                <a:latin typeface="Malgun Gothic"/>
-              </a:rPr>
-              <a:t>2</a:t>
-            </a:r>
-          </a:p>
-        </p:txBody>
-      </p:sp>
-      <p:sp>
-        <p:nvSpPr>
-          <p:cNvPr id="14" name="TextBox 13"/>
-          <p:cNvSpPr txBox="1"/>
-          <p:nvPr/>
-        </p:nvSpPr>
-        <p:spPr>
-          <a:xfrm>
-            <a:off x="3054096" y="2743200"/>
-            <a:ext cx="1581912" cy="274320"/>
-          </a:xfrm>
-          <a:prstGeom prst="rect">
-            <a:avLst/>
-          </a:prstGeom>
-          <a:noFill/>
-        </p:spPr>
-        <p:txBody>
-          <a:bodyPr wrap="square" lIns="18288" rIns="18288" tIns="18288" bIns="18288" anchor="t">
-            <a:spAutoFit/>
-          </a:bodyPr>
-          <a:lstStyle/>
-          <a:p>
-            <a:pPr algn="ctr">
-              <a:lnSpc>
-                <a:spcPct val="108000"/>
-              </a:lnSpc>
-            </a:pPr>
-            <a:r>
-              <a:rPr sz="1300" b="1">
-                <a:solidFill>
-                  <a:srgbClr val="FFFFFF"/>
-                </a:solidFill>
-                <a:latin typeface="Malgun Gothic"/>
-              </a:rPr>
-              <a:t>취향 저장</a:t>
-            </a:r>
-          </a:p>
-        </p:txBody>
-      </p:sp>
-      <p:sp>
-        <p:nvSpPr>
-          <p:cNvPr id="15" name="TextBox 14"/>
-          <p:cNvSpPr txBox="1"/>
-          <p:nvPr/>
-        </p:nvSpPr>
-        <p:spPr>
-          <a:xfrm>
-            <a:off x="3054096" y="3182112"/>
-            <a:ext cx="1581912" cy="347472"/>
-          </a:xfrm>
-          <a:prstGeom prst="rect">
-            <a:avLst/>
-          </a:prstGeom>
-          <a:noFill/>
-        </p:spPr>
-        <p:txBody>
-          <a:bodyPr wrap="square" lIns="18288" rIns="18288" tIns="18288" bIns="18288" anchor="t">
-            <a:spAutoFit/>
-          </a:bodyPr>
-          <a:lstStyle/>
-          <a:p>
-            <a:pPr algn="ctr">
-              <a:lnSpc>
-                <a:spcPct val="108000"/>
-              </a:lnSpc>
-            </a:pPr>
-            <a:r>
-              <a:rPr sz="919" b="0">
-                <a:solidFill>
-                  <a:srgbClr val="CBD5E1"/>
-                </a:solidFill>
-                <a:latin typeface="Malgun Gothic"/>
-              </a:rPr>
-              <a:t>관심 카테고리와 예산 선택</a:t>
-            </a:r>
-          </a:p>
-        </p:txBody>
-      </p:sp>
-      <p:cxnSp>
-        <p:nvCxnSpPr>
-          <p:cNvPr id="16" name="Connector 15"/>
-          <p:cNvCxnSpPr/>
-          <p:nvPr/>
-        </p:nvCxnSpPr>
-        <p:spPr>
-          <a:xfrm>
-            <a:off x="4818888" y="2871216"/>
-            <a:ext cx="310896" cy="0"/>
-          </a:xfrm>
-          <a:prstGeom prst="line">
-            <a:avLst/>
-          </a:prstGeom>
-          <a:ln w="25400">
-            <a:solidFill>
-              <a:srgbClr val="A78BFA"/>
-            </a:solidFill>
-          </a:ln>
-        </p:spPr>
-        <p:style>
-          <a:lnRef idx="2">
-            <a:schemeClr val="accent1"/>
-          </a:lnRef>
-          <a:fillRef idx="0">
-            <a:schemeClr val="accent1"/>
-          </a:fillRef>
-          <a:effectRef idx="1">
-            <a:schemeClr val="accent1"/>
-          </a:effectRef>
-          <a:fontRef idx="minor">
-            <a:schemeClr val="tx1"/>
-          </a:fontRef>
-        </p:style>
-      </p:cxnSp>
-      <p:sp>
-        <p:nvSpPr>
-          <p:cNvPr id="17" name="Rounded Rectangle 16"/>
+          <p:cNvPr id="10" name="TextBox 9"/>
+          <p:cNvSpPr txBox="1"/>
+          <p:nvPr/>
+        </p:nvSpPr>
+        <p:spPr>
+          <a:xfrm>
+            <a:off x="6446520" y="1691639"/>
+            <a:ext cx="4663440" cy="274320"/>
+          </a:xfrm>
+          <a:prstGeom prst="rect">
+            <a:avLst/>
+          </a:prstGeom>
+          <a:noFill/>
+        </p:spPr>
+        <p:txBody>
+          <a:bodyPr wrap="square" lIns="18288" rIns="18288" tIns="18288" bIns="18288" anchor="t">
+            <a:spAutoFit/>
+          </a:bodyPr>
+          <a:lstStyle/>
+          <a:p>
+            <a:pPr algn="l">
+              <a:lnSpc>
+                <a:spcPct val="108000"/>
+              </a:lnSpc>
+            </a:pPr>
+            <a:r>
+              <a:rPr sz="1400" b="1">
+                <a:solidFill>
+                  <a:srgbClr val="D946A3"/>
+                </a:solidFill>
+                <a:latin typeface="Malgun Gothic"/>
+              </a:rPr>
+              <a:t>실제로 달라지는 추천</a:t>
+            </a:r>
+          </a:p>
+        </p:txBody>
+      </p:sp>
+      <p:sp>
+        <p:nvSpPr>
+          <p:cNvPr id="11" name="TextBox 10"/>
+          <p:cNvSpPr txBox="1"/>
+          <p:nvPr/>
+        </p:nvSpPr>
+        <p:spPr>
+          <a:xfrm>
+            <a:off x="6446520" y="2039112"/>
+            <a:ext cx="4663440" cy="475487"/>
+          </a:xfrm>
+          <a:prstGeom prst="rect">
+            <a:avLst/>
+          </a:prstGeom>
+          <a:noFill/>
+        </p:spPr>
+        <p:txBody>
+          <a:bodyPr wrap="square" lIns="18288" rIns="18288" tIns="18288" bIns="18288" anchor="t">
+            <a:spAutoFit/>
+          </a:bodyPr>
+          <a:lstStyle/>
+          <a:p>
+            <a:pPr algn="l">
+              <a:lnSpc>
+                <a:spcPct val="108000"/>
+              </a:lnSpc>
+            </a:pPr>
+            <a:r>
+              <a:rPr sz="1030" b="1">
+                <a:solidFill>
+                  <a:srgbClr val="111827"/>
+                </a:solidFill>
+                <a:latin typeface="Malgun Gothic"/>
+              </a:rPr>
+              <a:t>회원별 행동에 따라 추천 목록이 달라짐</a:t>
+            </a:r>
+          </a:p>
+        </p:txBody>
+      </p:sp>
+      <p:sp>
+        <p:nvSpPr>
+          <p:cNvPr id="12" name="Rounded Rectangle 11"/>
           <p:cNvSpPr/>
           <p:nvPr/>
         </p:nvSpPr>
         <p:spPr>
           <a:xfrm>
-            <a:off x="5212080" y="1828800"/>
-            <a:ext cx="1947672" cy="2057400"/>
+            <a:off x="658368" y="2862072"/>
+            <a:ext cx="5166360" cy="1097280"/>
           </a:xfrm>
           <a:prstGeom prst="roundRect">
             <a:avLst>
@@ -17958,11 +17980,11 @@
             </a:avLst>
           </a:prstGeom>
           <a:solidFill>
-            <a:srgbClr val="182235"/>
+            <a:srgbClr val="FFFFFF"/>
           </a:solidFill>
           <a:ln w="12700">
             <a:solidFill>
-              <a:srgbClr val="334155"/>
+              <a:srgbClr val="D9DEEA"/>
             </a:solidFill>
           </a:ln>
         </p:spPr>
@@ -17990,16 +18012,16 @@
       </p:sp>
       <p:sp>
         <p:nvSpPr>
-          <p:cNvPr id="18" name="Oval 17"/>
+          <p:cNvPr id="13" name="Rectangle 12"/>
           <p:cNvSpPr/>
           <p:nvPr/>
         </p:nvSpPr>
         <p:spPr>
           <a:xfrm>
-            <a:off x="5961888" y="2084831"/>
-            <a:ext cx="420624" cy="420624"/>
-          </a:xfrm>
-          <a:prstGeom prst="ellipse">
+            <a:off x="658368" y="2862072"/>
+            <a:ext cx="91440" cy="1097280"/>
+          </a:xfrm>
+          <a:prstGeom prst="rect">
             <a:avLst/>
           </a:prstGeom>
           <a:solidFill>
@@ -18033,166 +18055,92 @@
       </p:sp>
       <p:sp>
         <p:nvSpPr>
-          <p:cNvPr id="19" name="TextBox 18"/>
-          <p:cNvSpPr txBox="1"/>
-          <p:nvPr/>
-        </p:nvSpPr>
-        <p:spPr>
-          <a:xfrm>
-            <a:off x="5961888" y="2084831"/>
-            <a:ext cx="420624" cy="420624"/>
-          </a:xfrm>
-          <a:prstGeom prst="rect">
-            <a:avLst/>
-          </a:prstGeom>
-          <a:noFill/>
-        </p:spPr>
-        <p:txBody>
-          <a:bodyPr wrap="square" lIns="18288" rIns="18288" tIns="18288" bIns="18288" anchor="ctr">
-            <a:spAutoFit/>
-          </a:bodyPr>
-          <a:lstStyle/>
-          <a:p>
-            <a:pPr algn="ctr">
-              <a:lnSpc>
-                <a:spcPct val="108000"/>
-              </a:lnSpc>
-            </a:pPr>
-            <a:r>
-              <a:rPr sz="1300" b="1">
-                <a:solidFill>
-                  <a:srgbClr val="FFFFFF"/>
-                </a:solidFill>
-                <a:latin typeface="Malgun Gothic"/>
-              </a:rPr>
-              <a:t>3</a:t>
-            </a:r>
-          </a:p>
-        </p:txBody>
-      </p:sp>
-      <p:sp>
-        <p:nvSpPr>
-          <p:cNvPr id="20" name="TextBox 19"/>
-          <p:cNvSpPr txBox="1"/>
-          <p:nvPr/>
-        </p:nvSpPr>
-        <p:spPr>
-          <a:xfrm>
-            <a:off x="5394960" y="2743200"/>
-            <a:ext cx="1581912" cy="274320"/>
-          </a:xfrm>
-          <a:prstGeom prst="rect">
-            <a:avLst/>
-          </a:prstGeom>
-          <a:noFill/>
-        </p:spPr>
-        <p:txBody>
-          <a:bodyPr wrap="square" lIns="18288" rIns="18288" tIns="18288" bIns="18288" anchor="t">
-            <a:spAutoFit/>
-          </a:bodyPr>
-          <a:lstStyle/>
-          <a:p>
-            <a:pPr algn="ctr">
-              <a:lnSpc>
-                <a:spcPct val="108000"/>
-              </a:lnSpc>
-            </a:pPr>
-            <a:r>
-              <a:rPr sz="1300" b="1">
-                <a:solidFill>
-                  <a:srgbClr val="FFFFFF"/>
-                </a:solidFill>
-                <a:latin typeface="Malgun Gothic"/>
-              </a:rPr>
-              <a:t>상품 행동</a:t>
-            </a:r>
-          </a:p>
-        </p:txBody>
-      </p:sp>
-      <p:sp>
-        <p:nvSpPr>
-          <p:cNvPr id="21" name="TextBox 20"/>
-          <p:cNvSpPr txBox="1"/>
-          <p:nvPr/>
-        </p:nvSpPr>
-        <p:spPr>
-          <a:xfrm>
-            <a:off x="5394960" y="3182112"/>
-            <a:ext cx="1581912" cy="347472"/>
-          </a:xfrm>
-          <a:prstGeom prst="rect">
-            <a:avLst/>
-          </a:prstGeom>
-          <a:noFill/>
-        </p:spPr>
-        <p:txBody>
-          <a:bodyPr wrap="square" lIns="18288" rIns="18288" tIns="18288" bIns="18288" anchor="t">
-            <a:spAutoFit/>
-          </a:bodyPr>
-          <a:lstStyle/>
-          <a:p>
-            <a:pPr algn="ctr">
-              <a:lnSpc>
-                <a:spcPct val="108000"/>
-              </a:lnSpc>
-            </a:pPr>
-            <a:r>
-              <a:rPr sz="919" b="0">
-                <a:solidFill>
-                  <a:srgbClr val="CBD5E1"/>
-                </a:solidFill>
-                <a:latin typeface="Malgun Gothic"/>
-              </a:rPr>
-              <a:t>상품을 조회하고 찜·장바구니</a:t>
-            </a:r>
-          </a:p>
-        </p:txBody>
-      </p:sp>
-      <p:cxnSp>
-        <p:nvCxnSpPr>
-          <p:cNvPr id="22" name="Connector 21"/>
-          <p:cNvCxnSpPr/>
-          <p:nvPr/>
-        </p:nvCxnSpPr>
-        <p:spPr>
-          <a:xfrm>
-            <a:off x="7159752" y="2871216"/>
-            <a:ext cx="310896" cy="0"/>
-          </a:xfrm>
-          <a:prstGeom prst="line">
-            <a:avLst/>
-          </a:prstGeom>
-          <a:ln w="25400">
-            <a:solidFill>
-              <a:srgbClr val="A78BFA"/>
-            </a:solidFill>
-          </a:ln>
-        </p:spPr>
-        <p:style>
-          <a:lnRef idx="2">
-            <a:schemeClr val="accent1"/>
-          </a:lnRef>
-          <a:fillRef idx="0">
-            <a:schemeClr val="accent1"/>
-          </a:fillRef>
-          <a:effectRef idx="1">
-            <a:schemeClr val="accent1"/>
-          </a:effectRef>
-          <a:fontRef idx="minor">
-            <a:schemeClr val="tx1"/>
-          </a:fontRef>
-        </p:style>
-      </p:cxnSp>
-      <p:sp>
-        <p:nvSpPr>
-          <p:cNvPr id="23" name="Rounded Rectangle 22"/>
+          <p:cNvPr id="14" name="TextBox 13"/>
+          <p:cNvSpPr txBox="1"/>
+          <p:nvPr/>
+        </p:nvSpPr>
+        <p:spPr>
+          <a:xfrm>
+            <a:off x="914400" y="3044952"/>
+            <a:ext cx="4663440" cy="274320"/>
+          </a:xfrm>
+          <a:prstGeom prst="rect">
+            <a:avLst/>
+          </a:prstGeom>
+          <a:noFill/>
+        </p:spPr>
+        <p:txBody>
+          <a:bodyPr wrap="square" lIns="18288" rIns="18288" tIns="18288" bIns="18288" anchor="t">
+            <a:spAutoFit/>
+          </a:bodyPr>
+          <a:lstStyle/>
+          <a:p>
+            <a:pPr algn="l">
+              <a:lnSpc>
+                <a:spcPct val="108000"/>
+              </a:lnSpc>
+            </a:pPr>
+            <a:r>
+              <a:rPr sz="1400" b="1">
+                <a:solidFill>
+                  <a:srgbClr val="2563EB"/>
+                </a:solidFill>
+                <a:latin typeface="Malgun Gothic"/>
+              </a:rPr>
+              <a:t>빠르고 가벼운 AI</a:t>
+            </a:r>
+          </a:p>
+        </p:txBody>
+      </p:sp>
+      <p:sp>
+        <p:nvSpPr>
+          <p:cNvPr id="15" name="TextBox 14"/>
+          <p:cNvSpPr txBox="1"/>
+          <p:nvPr/>
+        </p:nvSpPr>
+        <p:spPr>
+          <a:xfrm>
+            <a:off x="914400" y="3392424"/>
+            <a:ext cx="4663440" cy="475487"/>
+          </a:xfrm>
+          <a:prstGeom prst="rect">
+            <a:avLst/>
+          </a:prstGeom>
+          <a:noFill/>
+        </p:spPr>
+        <p:txBody>
+          <a:bodyPr wrap="square" lIns="18288" rIns="18288" tIns="18288" bIns="18288" anchor="t">
+            <a:spAutoFit/>
+          </a:bodyPr>
+          <a:lstStyle/>
+          <a:p>
+            <a:pPr algn="l">
+              <a:lnSpc>
+                <a:spcPct val="108000"/>
+              </a:lnSpc>
+            </a:pPr>
+            <a:r>
+              <a:rPr sz="1030" b="1">
+                <a:solidFill>
+                  <a:srgbClr val="111827"/>
+                </a:solidFill>
+                <a:latin typeface="Malgun Gothic"/>
+              </a:rPr>
+              <a:t>작은 TextCNN 모델을 평균 0.0127초에 실행</a:t>
+            </a:r>
+          </a:p>
+        </p:txBody>
+      </p:sp>
+      <p:sp>
+        <p:nvSpPr>
+          <p:cNvPr id="16" name="Rounded Rectangle 15"/>
           <p:cNvSpPr/>
           <p:nvPr/>
         </p:nvSpPr>
         <p:spPr>
           <a:xfrm>
-            <a:off x="7552944" y="1828800"/>
-            <a:ext cx="1947672" cy="2057400"/>
+            <a:off x="6190488" y="2862072"/>
+            <a:ext cx="5166360" cy="1097280"/>
           </a:xfrm>
           <a:prstGeom prst="roundRect">
             <a:avLst>
@@ -18200,11 +18148,11 @@
             </a:avLst>
           </a:prstGeom>
           <a:solidFill>
-            <a:srgbClr val="182235"/>
+            <a:srgbClr val="FFFFFF"/>
           </a:solidFill>
           <a:ln w="12700">
             <a:solidFill>
-              <a:srgbClr val="334155"/>
+              <a:srgbClr val="D9DEEA"/>
             </a:solidFill>
           </a:ln>
         </p:spPr>
@@ -18232,258 +18180,16 @@
       </p:sp>
       <p:sp>
         <p:nvSpPr>
-          <p:cNvPr id="24" name="Oval 23"/>
+          <p:cNvPr id="17" name="Rectangle 16"/>
           <p:cNvSpPr/>
           <p:nvPr/>
         </p:nvSpPr>
         <p:spPr>
           <a:xfrm>
-            <a:off x="8302752" y="2084831"/>
-            <a:ext cx="420624" cy="420624"/>
-          </a:xfrm>
-          <a:prstGeom prst="ellipse">
-            <a:avLst/>
-          </a:prstGeom>
-          <a:solidFill>
-            <a:srgbClr val="D946A3"/>
-          </a:solidFill>
-          <a:ln>
-            <a:noFill/>
-          </a:ln>
-        </p:spPr>
-        <p:style>
-          <a:lnRef idx="1">
-            <a:schemeClr val="accent1"/>
-          </a:lnRef>
-          <a:fillRef idx="3">
-            <a:schemeClr val="accent1"/>
-          </a:fillRef>
-          <a:effectRef idx="2">
-            <a:schemeClr val="accent1"/>
-          </a:effectRef>
-          <a:fontRef idx="minor">
-            <a:schemeClr val="lt1"/>
-          </a:fontRef>
-        </p:style>
-        <p:txBody>
-          <a:bodyPr rtlCol="0" anchor="ctr"/>
-          <a:lstStyle/>
-          <a:p>
-            <a:pPr algn="ctr"/>
-          </a:p>
-        </p:txBody>
-      </p:sp>
-      <p:sp>
-        <p:nvSpPr>
-          <p:cNvPr id="25" name="TextBox 24"/>
-          <p:cNvSpPr txBox="1"/>
-          <p:nvPr/>
-        </p:nvSpPr>
-        <p:spPr>
-          <a:xfrm>
-            <a:off x="8302752" y="2084831"/>
-            <a:ext cx="420624" cy="420624"/>
-          </a:xfrm>
-          <a:prstGeom prst="rect">
-            <a:avLst/>
-          </a:prstGeom>
-          <a:noFill/>
-        </p:spPr>
-        <p:txBody>
-          <a:bodyPr wrap="square" lIns="18288" rIns="18288" tIns="18288" bIns="18288" anchor="ctr">
-            <a:spAutoFit/>
-          </a:bodyPr>
-          <a:lstStyle/>
-          <a:p>
-            <a:pPr algn="ctr">
-              <a:lnSpc>
-                <a:spcPct val="108000"/>
-              </a:lnSpc>
-            </a:pPr>
-            <a:r>
-              <a:rPr sz="1300" b="1">
-                <a:solidFill>
-                  <a:srgbClr val="FFFFFF"/>
-                </a:solidFill>
-                <a:latin typeface="Malgun Gothic"/>
-              </a:rPr>
-              <a:t>4</a:t>
-            </a:r>
-          </a:p>
-        </p:txBody>
-      </p:sp>
-      <p:sp>
-        <p:nvSpPr>
-          <p:cNvPr id="26" name="TextBox 25"/>
-          <p:cNvSpPr txBox="1"/>
-          <p:nvPr/>
-        </p:nvSpPr>
-        <p:spPr>
-          <a:xfrm>
-            <a:off x="7735823" y="2743200"/>
-            <a:ext cx="1581912" cy="274320"/>
-          </a:xfrm>
-          <a:prstGeom prst="rect">
-            <a:avLst/>
-          </a:prstGeom>
-          <a:noFill/>
-        </p:spPr>
-        <p:txBody>
-          <a:bodyPr wrap="square" lIns="18288" rIns="18288" tIns="18288" bIns="18288" anchor="t">
-            <a:spAutoFit/>
-          </a:bodyPr>
-          <a:lstStyle/>
-          <a:p>
-            <a:pPr algn="ctr">
-              <a:lnSpc>
-                <a:spcPct val="108000"/>
-              </a:lnSpc>
-            </a:pPr>
-            <a:r>
-              <a:rPr sz="1300" b="1">
-                <a:solidFill>
-                  <a:srgbClr val="FFFFFF"/>
-                </a:solidFill>
-                <a:latin typeface="Malgun Gothic"/>
-              </a:rPr>
-              <a:t>AI 추천</a:t>
-            </a:r>
-          </a:p>
-        </p:txBody>
-      </p:sp>
-      <p:sp>
-        <p:nvSpPr>
-          <p:cNvPr id="27" name="TextBox 26"/>
-          <p:cNvSpPr txBox="1"/>
-          <p:nvPr/>
-        </p:nvSpPr>
-        <p:spPr>
-          <a:xfrm>
-            <a:off x="7735823" y="3182112"/>
-            <a:ext cx="1581912" cy="347472"/>
-          </a:xfrm>
-          <a:prstGeom prst="rect">
-            <a:avLst/>
-          </a:prstGeom>
-          <a:noFill/>
-        </p:spPr>
-        <p:txBody>
-          <a:bodyPr wrap="square" lIns="18288" rIns="18288" tIns="18288" bIns="18288" anchor="t">
-            <a:spAutoFit/>
-          </a:bodyPr>
-          <a:lstStyle/>
-          <a:p>
-            <a:pPr algn="ctr">
-              <a:lnSpc>
-                <a:spcPct val="108000"/>
-              </a:lnSpc>
-            </a:pPr>
-            <a:r>
-              <a:rPr sz="919" b="0">
-                <a:solidFill>
-                  <a:srgbClr val="CBD5E1"/>
-                </a:solidFill>
-                <a:latin typeface="Malgun Gothic"/>
-              </a:rPr>
-              <a:t>추천 결과와 이유 확인</a:t>
-            </a:r>
-          </a:p>
-        </p:txBody>
-      </p:sp>
-      <p:cxnSp>
-        <p:nvCxnSpPr>
-          <p:cNvPr id="28" name="Connector 27"/>
-          <p:cNvCxnSpPr/>
-          <p:nvPr/>
-        </p:nvCxnSpPr>
-        <p:spPr>
-          <a:xfrm>
-            <a:off x="9500616" y="2871216"/>
-            <a:ext cx="310896" cy="0"/>
-          </a:xfrm>
-          <a:prstGeom prst="line">
-            <a:avLst/>
-          </a:prstGeom>
-          <a:ln w="25400">
-            <a:solidFill>
-              <a:srgbClr val="A78BFA"/>
-            </a:solidFill>
-          </a:ln>
-        </p:spPr>
-        <p:style>
-          <a:lnRef idx="2">
-            <a:schemeClr val="accent1"/>
-          </a:lnRef>
-          <a:fillRef idx="0">
-            <a:schemeClr val="accent1"/>
-          </a:fillRef>
-          <a:effectRef idx="1">
-            <a:schemeClr val="accent1"/>
-          </a:effectRef>
-          <a:fontRef idx="minor">
-            <a:schemeClr val="tx1"/>
-          </a:fontRef>
-        </p:style>
-      </p:cxnSp>
-      <p:sp>
-        <p:nvSpPr>
-          <p:cNvPr id="29" name="Rounded Rectangle 28"/>
-          <p:cNvSpPr/>
-          <p:nvPr/>
-        </p:nvSpPr>
-        <p:spPr>
-          <a:xfrm>
-            <a:off x="9893808" y="1828800"/>
-            <a:ext cx="1947672" cy="2057400"/>
-          </a:xfrm>
-          <a:prstGeom prst="roundRect">
-            <a:avLst>
-              <a:gd name="adj" fmla="val 12000"/>
-            </a:avLst>
-          </a:prstGeom>
-          <a:solidFill>
-            <a:srgbClr val="182235"/>
-          </a:solidFill>
-          <a:ln w="12700">
-            <a:solidFill>
-              <a:srgbClr val="334155"/>
-            </a:solidFill>
-          </a:ln>
-        </p:spPr>
-        <p:style>
-          <a:lnRef idx="1">
-            <a:schemeClr val="accent1"/>
-          </a:lnRef>
-          <a:fillRef idx="3">
-            <a:schemeClr val="accent1"/>
-          </a:fillRef>
-          <a:effectRef idx="2">
-            <a:schemeClr val="accent1"/>
-          </a:effectRef>
-          <a:fontRef idx="minor">
-            <a:schemeClr val="lt1"/>
-          </a:fontRef>
-        </p:style>
-        <p:txBody>
-          <a:bodyPr rtlCol="0" anchor="ctr"/>
-          <a:lstStyle/>
-          <a:p>
-            <a:pPr algn="ctr"/>
-          </a:p>
-        </p:txBody>
-      </p:sp>
-      <p:sp>
-        <p:nvSpPr>
-          <p:cNvPr id="30" name="Oval 29"/>
-          <p:cNvSpPr/>
-          <p:nvPr/>
-        </p:nvSpPr>
-        <p:spPr>
-          <a:xfrm>
-            <a:off x="10643616" y="2084831"/>
-            <a:ext cx="420624" cy="420624"/>
-          </a:xfrm>
-          <a:prstGeom prst="ellipse">
+            <a:off x="6190488" y="2862072"/>
+            <a:ext cx="91440" cy="1097280"/>
+          </a:xfrm>
+          <a:prstGeom prst="rect">
             <a:avLst/>
           </a:prstGeom>
           <a:solidFill>
@@ -18517,131 +18223,92 @@
       </p:sp>
       <p:sp>
         <p:nvSpPr>
-          <p:cNvPr id="31" name="TextBox 30"/>
-          <p:cNvSpPr txBox="1"/>
-          <p:nvPr/>
-        </p:nvSpPr>
-        <p:spPr>
-          <a:xfrm>
-            <a:off x="10643616" y="2084831"/>
-            <a:ext cx="420624" cy="420624"/>
-          </a:xfrm>
-          <a:prstGeom prst="rect">
-            <a:avLst/>
-          </a:prstGeom>
-          <a:noFill/>
-        </p:spPr>
-        <p:txBody>
-          <a:bodyPr wrap="square" lIns="18288" rIns="18288" tIns="18288" bIns="18288" anchor="ctr">
-            <a:spAutoFit/>
-          </a:bodyPr>
-          <a:lstStyle/>
-          <a:p>
-            <a:pPr algn="ctr">
-              <a:lnSpc>
-                <a:spcPct val="108000"/>
-              </a:lnSpc>
-            </a:pPr>
-            <a:r>
-              <a:rPr sz="1300" b="1">
-                <a:solidFill>
-                  <a:srgbClr val="FFFFFF"/>
-                </a:solidFill>
-                <a:latin typeface="Malgun Gothic"/>
-              </a:rPr>
-              <a:t>5</a:t>
-            </a:r>
-          </a:p>
-        </p:txBody>
-      </p:sp>
-      <p:sp>
-        <p:nvSpPr>
-          <p:cNvPr id="32" name="TextBox 31"/>
-          <p:cNvSpPr txBox="1"/>
-          <p:nvPr/>
-        </p:nvSpPr>
-        <p:spPr>
-          <a:xfrm>
-            <a:off x="10076688" y="2743200"/>
-            <a:ext cx="1581912" cy="274320"/>
-          </a:xfrm>
-          <a:prstGeom prst="rect">
-            <a:avLst/>
-          </a:prstGeom>
-          <a:noFill/>
-        </p:spPr>
-        <p:txBody>
-          <a:bodyPr wrap="square" lIns="18288" rIns="18288" tIns="18288" bIns="18288" anchor="t">
-            <a:spAutoFit/>
-          </a:bodyPr>
-          <a:lstStyle/>
-          <a:p>
-            <a:pPr algn="ctr">
-              <a:lnSpc>
-                <a:spcPct val="108000"/>
-              </a:lnSpc>
-            </a:pPr>
-            <a:r>
-              <a:rPr sz="1300" b="1">
-                <a:solidFill>
-                  <a:srgbClr val="FFFFFF"/>
-                </a:solidFill>
-                <a:latin typeface="Malgun Gothic"/>
-              </a:rPr>
-              <a:t>모의 결제</a:t>
-            </a:r>
-          </a:p>
-        </p:txBody>
-      </p:sp>
-      <p:sp>
-        <p:nvSpPr>
-          <p:cNvPr id="33" name="TextBox 32"/>
-          <p:cNvSpPr txBox="1"/>
-          <p:nvPr/>
-        </p:nvSpPr>
-        <p:spPr>
-          <a:xfrm>
-            <a:off x="10076688" y="3182112"/>
-            <a:ext cx="1581912" cy="347472"/>
-          </a:xfrm>
-          <a:prstGeom prst="rect">
-            <a:avLst/>
-          </a:prstGeom>
-          <a:noFill/>
-        </p:spPr>
-        <p:txBody>
-          <a:bodyPr wrap="square" lIns="18288" rIns="18288" tIns="18288" bIns="18288" anchor="t">
-            <a:spAutoFit/>
-          </a:bodyPr>
-          <a:lstStyle/>
-          <a:p>
-            <a:pPr algn="ctr">
-              <a:lnSpc>
-                <a:spcPct val="108000"/>
-              </a:lnSpc>
-            </a:pPr>
-            <a:r>
-              <a:rPr sz="919" b="0">
-                <a:solidFill>
-                  <a:srgbClr val="CBD5E1"/>
-                </a:solidFill>
-                <a:latin typeface="Malgun Gothic"/>
-              </a:rPr>
-              <a:t>재고 차감과 주문 내역 확인</a:t>
-            </a:r>
-          </a:p>
-        </p:txBody>
-      </p:sp>
-      <p:sp>
-        <p:nvSpPr>
-          <p:cNvPr id="34" name="Rounded Rectangle 33"/>
+          <p:cNvPr id="18" name="TextBox 17"/>
+          <p:cNvSpPr txBox="1"/>
+          <p:nvPr/>
+        </p:nvSpPr>
+        <p:spPr>
+          <a:xfrm>
+            <a:off x="6446520" y="3044952"/>
+            <a:ext cx="4663440" cy="274320"/>
+          </a:xfrm>
+          <a:prstGeom prst="rect">
+            <a:avLst/>
+          </a:prstGeom>
+          <a:noFill/>
+        </p:spPr>
+        <p:txBody>
+          <a:bodyPr wrap="square" lIns="18288" rIns="18288" tIns="18288" bIns="18288" anchor="t">
+            <a:spAutoFit/>
+          </a:bodyPr>
+          <a:lstStyle/>
+          <a:p>
+            <a:pPr algn="l">
+              <a:lnSpc>
+                <a:spcPct val="108000"/>
+              </a:lnSpc>
+            </a:pPr>
+            <a:r>
+              <a:rPr sz="1400" b="1">
+                <a:solidFill>
+                  <a:srgbClr val="16A34A"/>
+                </a:solidFill>
+                <a:latin typeface="Malgun Gothic"/>
+              </a:rPr>
+              <a:t>관리 가능한 데이터</a:t>
+            </a:r>
+          </a:p>
+        </p:txBody>
+      </p:sp>
+      <p:sp>
+        <p:nvSpPr>
+          <p:cNvPr id="19" name="TextBox 18"/>
+          <p:cNvSpPr txBox="1"/>
+          <p:nvPr/>
+        </p:nvSpPr>
+        <p:spPr>
+          <a:xfrm>
+            <a:off x="6446520" y="3392424"/>
+            <a:ext cx="4663440" cy="475487"/>
+          </a:xfrm>
+          <a:prstGeom prst="rect">
+            <a:avLst/>
+          </a:prstGeom>
+          <a:noFill/>
+        </p:spPr>
+        <p:txBody>
+          <a:bodyPr wrap="square" lIns="18288" rIns="18288" tIns="18288" bIns="18288" anchor="t">
+            <a:spAutoFit/>
+          </a:bodyPr>
+          <a:lstStyle/>
+          <a:p>
+            <a:pPr algn="l">
+              <a:lnSpc>
+                <a:spcPct val="108000"/>
+              </a:lnSpc>
+            </a:pPr>
+            <a:r>
+              <a:rPr sz="1030" b="1">
+                <a:solidFill>
+                  <a:srgbClr val="111827"/>
+                </a:solidFill>
+                <a:latin typeface="Malgun Gothic"/>
+              </a:rPr>
+              <a:t>MySQL과 DBeaver로 회원·행동·주문 확인</a:t>
+            </a:r>
+          </a:p>
+        </p:txBody>
+      </p:sp>
+      <p:sp>
+        <p:nvSpPr>
+          <p:cNvPr id="20" name="Rounded Rectangle 19"/>
           <p:cNvSpPr/>
           <p:nvPr/>
         </p:nvSpPr>
         <p:spPr>
           <a:xfrm>
-            <a:off x="1143000" y="4389120"/>
-            <a:ext cx="9902952" cy="914400"/>
+            <a:off x="658368" y="4498848"/>
+            <a:ext cx="10698480" cy="566928"/>
           </a:xfrm>
           <a:prstGeom prst="roundRect">
             <a:avLst>
@@ -18649,12 +18316,10 @@
             </a:avLst>
           </a:prstGeom>
           <a:solidFill>
-            <a:srgbClr val="302B63"/>
+            <a:srgbClr val="0F172A"/>
           </a:solidFill>
-          <a:ln w="12700">
-            <a:solidFill>
-              <a:srgbClr val="4C3F91"/>
-            </a:solidFill>
+          <a:ln>
+            <a:noFill/>
           </a:ln>
         </p:spPr>
         <p:style>
@@ -18681,14 +18346,14 @@
       </p:sp>
       <p:sp>
         <p:nvSpPr>
-          <p:cNvPr id="35" name="TextBox 34"/>
-          <p:cNvSpPr txBox="1"/>
-          <p:nvPr/>
-        </p:nvSpPr>
-        <p:spPr>
-          <a:xfrm>
-            <a:off x="1444752" y="4590288"/>
-            <a:ext cx="9281160" cy="502920"/>
+          <p:cNvPr id="21" name="TextBox 20"/>
+          <p:cNvSpPr txBox="1"/>
+          <p:nvPr/>
+        </p:nvSpPr>
+        <p:spPr>
+          <a:xfrm>
+            <a:off x="914400" y="4645152"/>
+            <a:ext cx="10149840" cy="274320"/>
           </a:xfrm>
           <a:prstGeom prst="rect">
             <a:avLst/>
@@ -18707,60 +18372,143 @@
               </a:lnSpc>
             </a:pPr>
             <a:r>
-              <a:rPr sz="1400" b="1">
+              <a:rPr sz="1080" b="1">
                 <a:solidFill>
                   <a:srgbClr val="FFFFFF"/>
                 </a:solidFill>
                 <a:latin typeface="Malgun Gothic"/>
               </a:rPr>
-              <a:t>마무리 문장  |  “사용자의 행동을 이해하고, 추천 이유를 설명하며,
-실제 주문 흐름까지 연결되는 AI 이커머스를 구현했습니다.”</a:t>
-            </a:r>
-          </a:p>
-        </p:txBody>
-      </p:sp>
-      <p:sp>
-        <p:nvSpPr>
-          <p:cNvPr id="36" name="TextBox 35"/>
-          <p:cNvSpPr txBox="1"/>
-          <p:nvPr/>
-        </p:nvSpPr>
-        <p:spPr>
-          <a:xfrm>
-            <a:off x="1920240" y="5852160"/>
-            <a:ext cx="8321040" cy="274320"/>
-          </a:xfrm>
-          <a:prstGeom prst="rect">
-            <a:avLst/>
-          </a:prstGeom>
-          <a:noFill/>
-        </p:spPr>
-        <p:txBody>
-          <a:bodyPr wrap="square" lIns="18288" rIns="18288" tIns="18288" bIns="18288" anchor="t">
-            <a:spAutoFit/>
-          </a:bodyPr>
-          <a:lstStyle/>
-          <a:p>
-            <a:pPr algn="ctr">
-              <a:lnSpc>
-                <a:spcPct val="108000"/>
-              </a:lnSpc>
-            </a:pPr>
-            <a:r>
-              <a:rPr sz="1000" b="1">
+              <a:t>현재는 포트폴리오용 모의 쇼핑몰이며, 실제 결제·배송·대규모 사용자 데이터는 향후 확장 영역입니다.</a:t>
+            </a:r>
+          </a:p>
+        </p:txBody>
+      </p:sp>
+      <p:sp>
+        <p:nvSpPr>
+          <p:cNvPr id="22" name="Rounded Rectangle 21"/>
+          <p:cNvSpPr/>
+          <p:nvPr/>
+        </p:nvSpPr>
+        <p:spPr>
+          <a:xfrm>
+            <a:off x="658368" y="5532120"/>
+            <a:ext cx="10881360" cy="749808"/>
+          </a:xfrm>
+          <a:prstGeom prst="roundRect">
+            <a:avLst>
+              <a:gd name="adj" fmla="val 12000"/>
+            </a:avLst>
+          </a:prstGeom>
+          <a:solidFill>
+            <a:srgbClr val="0F172A"/>
+          </a:solidFill>
+          <a:ln>
+            <a:noFill/>
+          </a:ln>
+        </p:spPr>
+        <p:style>
+          <a:lnRef idx="1">
+            <a:schemeClr val="accent1"/>
+          </a:lnRef>
+          <a:fillRef idx="3">
+            <a:schemeClr val="accent1"/>
+          </a:fillRef>
+          <a:effectRef idx="2">
+            <a:schemeClr val="accent1"/>
+          </a:effectRef>
+          <a:fontRef idx="minor">
+            <a:schemeClr val="lt1"/>
+          </a:fontRef>
+        </p:style>
+        <p:txBody>
+          <a:bodyPr rtlCol="0" anchor="ctr"/>
+          <a:lstStyle/>
+          <a:p>
+            <a:pPr algn="ctr"/>
+          </a:p>
+        </p:txBody>
+      </p:sp>
+      <p:sp>
+        <p:nvSpPr>
+          <p:cNvPr id="23" name="TextBox 22"/>
+          <p:cNvSpPr txBox="1"/>
+          <p:nvPr/>
+        </p:nvSpPr>
+        <p:spPr>
+          <a:xfrm>
+            <a:off x="896112" y="5724144"/>
+            <a:ext cx="868680" cy="237744"/>
+          </a:xfrm>
+          <a:prstGeom prst="rect">
+            <a:avLst/>
+          </a:prstGeom>
+          <a:noFill/>
+        </p:spPr>
+        <p:txBody>
+          <a:bodyPr wrap="square" lIns="18288" rIns="18288" tIns="18288" bIns="18288" anchor="t">
+            <a:spAutoFit/>
+          </a:bodyPr>
+          <a:lstStyle/>
+          <a:p>
+            <a:pPr algn="l">
+              <a:lnSpc>
+                <a:spcPct val="108000"/>
+              </a:lnSpc>
+            </a:pPr>
+            <a:r>
+              <a:rPr sz="950" b="1">
                 <a:solidFill>
                   <a:srgbClr val="A78BFA"/>
                 </a:solidFill>
                 <a:latin typeface="Malgun Gothic"/>
               </a:rPr>
-              <a:t>시연 중 오류가 나더라도 핵심은 ‘행동이 저장되고 다음 추천에 반영된다’는 점을 설명하면 됩니다.</a:t>
-            </a:r>
-          </a:p>
-        </p:txBody>
-      </p:sp>
-      <p:sp>
-        <p:nvSpPr>
-          <p:cNvPr id="37" name="TextBox 36"/>
+              <a:t>발표할 때</a:t>
+            </a:r>
+          </a:p>
+        </p:txBody>
+      </p:sp>
+      <p:sp>
+        <p:nvSpPr>
+          <p:cNvPr id="24" name="TextBox 23"/>
+          <p:cNvSpPr txBox="1"/>
+          <p:nvPr/>
+        </p:nvSpPr>
+        <p:spPr>
+          <a:xfrm>
+            <a:off x="1828800" y="5650992"/>
+            <a:ext cx="9345168" cy="475488"/>
+          </a:xfrm>
+          <a:prstGeom prst="rect">
+            <a:avLst/>
+          </a:prstGeom>
+          <a:noFill/>
+        </p:spPr>
+        <p:txBody>
+          <a:bodyPr wrap="square" lIns="18288" rIns="18288" tIns="18288" bIns="18288" anchor="ctr">
+            <a:spAutoFit/>
+          </a:bodyPr>
+          <a:lstStyle/>
+          <a:p>
+            <a:pPr algn="l">
+              <a:lnSpc>
+                <a:spcPct val="108000"/>
+              </a:lnSpc>
+            </a:pPr>
+            <a:r>
+              <a:rPr sz="1050" b="1">
+                <a:solidFill>
+                  <a:srgbClr val="FFFFFF"/>
+                </a:solidFill>
+                <a:latin typeface="Malgun Gothic"/>
+              </a:rPr>
+              <a:t>이 프로젝트에서 가장 중요한 결과는 AI 모델만 만든 것이 아니라 추천이 실제 쇼핑 과정으로 이어지는 서비스를 완성했다는 점입니다. 현재는 포트폴리오용 모의 결제 서비스이며, 앞으로 실제 사용자 로그와 결제·배송 기능을 연결할 수 있습니다.</a:t>
+            </a:r>
+          </a:p>
+        </p:txBody>
+      </p:sp>
+      <p:sp>
+        <p:nvSpPr>
+          <p:cNvPr id="25" name="TextBox 24"/>
           <p:cNvSpPr txBox="1"/>
           <p:nvPr/>
         </p:nvSpPr>
@@ -19732,6 +19480,1489 @@
                 <a:latin typeface="Malgun Gothic"/>
               </a:rPr>
               <a:t>02</a:t>
+            </a:r>
+          </a:p>
+        </p:txBody>
+      </p:sp>
+    </p:spTree>
+  </p:cSld>
+  <p:clrMapOvr>
+    <a:masterClrMapping/>
+  </p:clrMapOvr>
+</p:sld>
+</file>
+
+<file path=ppt/slides/slide20.xml><?xml version="1.0" encoding="utf-8"?>
+<p:sld xmlns:a="http://schemas.openxmlformats.org/drawingml/2006/main" xmlns:p="http://schemas.openxmlformats.org/presentationml/2006/main" xmlns:r="http://schemas.openxmlformats.org/officeDocument/2006/relationships">
+  <p:cSld>
+    <p:bg>
+      <p:bgPr>
+        <a:solidFill>
+          <a:srgbClr val="0F172A"/>
+        </a:solidFill>
+        <a:effectLst/>
+      </p:bgPr>
+    </p:bg>
+    <p:spTree>
+      <p:nvGrpSpPr>
+        <p:cNvPr id="1" name=""/>
+        <p:cNvGrpSpPr/>
+        <p:nvPr/>
+      </p:nvGrpSpPr>
+      <p:grpSpPr/>
+      <p:sp>
+        <p:nvSpPr>
+          <p:cNvPr id="2" name="TextBox 1"/>
+          <p:cNvSpPr txBox="1"/>
+          <p:nvPr/>
+        </p:nvSpPr>
+        <p:spPr>
+          <a:xfrm>
+            <a:off x="658368" y="411480"/>
+            <a:ext cx="2743200" cy="274320"/>
+          </a:xfrm>
+          <a:prstGeom prst="rect">
+            <a:avLst/>
+          </a:prstGeom>
+          <a:noFill/>
+        </p:spPr>
+        <p:txBody>
+          <a:bodyPr wrap="square" lIns="18288" rIns="18288" tIns="18288" bIns="18288" anchor="t">
+            <a:spAutoFit/>
+          </a:bodyPr>
+          <a:lstStyle/>
+          <a:p>
+            <a:pPr algn="l">
+              <a:lnSpc>
+                <a:spcPct val="108000"/>
+              </a:lnSpc>
+            </a:pPr>
+            <a:r>
+              <a:rPr sz="1000" b="1">
+                <a:solidFill>
+                  <a:srgbClr val="8B5CF6"/>
+                </a:solidFill>
+                <a:latin typeface="Malgun Gothic"/>
+              </a:rPr>
+              <a:t>19 · 발표 마무리</a:t>
+            </a:r>
+          </a:p>
+        </p:txBody>
+      </p:sp>
+      <p:sp>
+        <p:nvSpPr>
+          <p:cNvPr id="3" name="TextBox 2"/>
+          <p:cNvSpPr txBox="1"/>
+          <p:nvPr/>
+        </p:nvSpPr>
+        <p:spPr>
+          <a:xfrm>
+            <a:off x="658368" y="749808"/>
+            <a:ext cx="10881360" cy="640080"/>
+          </a:xfrm>
+          <a:prstGeom prst="rect">
+            <a:avLst/>
+          </a:prstGeom>
+          <a:noFill/>
+        </p:spPr>
+        <p:txBody>
+          <a:bodyPr wrap="square" lIns="18288" rIns="18288" tIns="18288" bIns="18288" anchor="t">
+            <a:spAutoFit/>
+          </a:bodyPr>
+          <a:lstStyle/>
+          <a:p>
+            <a:pPr algn="l">
+              <a:lnSpc>
+                <a:spcPct val="108000"/>
+              </a:lnSpc>
+            </a:pPr>
+            <a:r>
+              <a:rPr sz="2700" b="1">
+                <a:solidFill>
+                  <a:srgbClr val="FFFFFF"/>
+                </a:solidFill>
+                <a:latin typeface="Malgun Gothic"/>
+              </a:rPr>
+              <a:t>라이브 시연은 이 순서로 진행</a:t>
+            </a:r>
+          </a:p>
+        </p:txBody>
+      </p:sp>
+      <p:sp>
+        <p:nvSpPr>
+          <p:cNvPr id="4" name="TextBox 3"/>
+          <p:cNvSpPr txBox="1"/>
+          <p:nvPr/>
+        </p:nvSpPr>
+        <p:spPr>
+          <a:xfrm>
+            <a:off x="685800" y="1399032"/>
+            <a:ext cx="10607040" cy="420624"/>
+          </a:xfrm>
+          <a:prstGeom prst="rect">
+            <a:avLst/>
+          </a:prstGeom>
+          <a:noFill/>
+        </p:spPr>
+        <p:txBody>
+          <a:bodyPr wrap="square" lIns="18288" rIns="18288" tIns="18288" bIns="18288" anchor="t">
+            <a:spAutoFit/>
+          </a:bodyPr>
+          <a:lstStyle/>
+          <a:p>
+            <a:pPr algn="l">
+              <a:lnSpc>
+                <a:spcPct val="108000"/>
+              </a:lnSpc>
+            </a:pPr>
+            <a:r>
+              <a:rPr sz="1300" b="0">
+                <a:solidFill>
+                  <a:srgbClr val="CBD5E1"/>
+                </a:solidFill>
+                <a:latin typeface="Malgun Gothic"/>
+              </a:rPr>
+              <a:t>기능을 모두 보여주기보다 개인화가 달라지는 핵심 흐름에 집중합니다.</a:t>
+            </a:r>
+          </a:p>
+        </p:txBody>
+      </p:sp>
+      <p:sp>
+        <p:nvSpPr>
+          <p:cNvPr id="5" name="Rounded Rectangle 4"/>
+          <p:cNvSpPr/>
+          <p:nvPr/>
+        </p:nvSpPr>
+        <p:spPr>
+          <a:xfrm>
+            <a:off x="530352" y="1828800"/>
+            <a:ext cx="1947672" cy="2057400"/>
+          </a:xfrm>
+          <a:prstGeom prst="roundRect">
+            <a:avLst>
+              <a:gd name="adj" fmla="val 12000"/>
+            </a:avLst>
+          </a:prstGeom>
+          <a:solidFill>
+            <a:srgbClr val="182235"/>
+          </a:solidFill>
+          <a:ln w="12700">
+            <a:solidFill>
+              <a:srgbClr val="334155"/>
+            </a:solidFill>
+          </a:ln>
+        </p:spPr>
+        <p:style>
+          <a:lnRef idx="1">
+            <a:schemeClr val="accent1"/>
+          </a:lnRef>
+          <a:fillRef idx="3">
+            <a:schemeClr val="accent1"/>
+          </a:fillRef>
+          <a:effectRef idx="2">
+            <a:schemeClr val="accent1"/>
+          </a:effectRef>
+          <a:fontRef idx="minor">
+            <a:schemeClr val="lt1"/>
+          </a:fontRef>
+        </p:style>
+        <p:txBody>
+          <a:bodyPr rtlCol="0" anchor="ctr"/>
+          <a:lstStyle/>
+          <a:p>
+            <a:pPr algn="ctr"/>
+          </a:p>
+        </p:txBody>
+      </p:sp>
+      <p:sp>
+        <p:nvSpPr>
+          <p:cNvPr id="6" name="Oval 5"/>
+          <p:cNvSpPr/>
+          <p:nvPr/>
+        </p:nvSpPr>
+        <p:spPr>
+          <a:xfrm>
+            <a:off x="1280160" y="2084831"/>
+            <a:ext cx="420624" cy="420624"/>
+          </a:xfrm>
+          <a:prstGeom prst="ellipse">
+            <a:avLst/>
+          </a:prstGeom>
+          <a:solidFill>
+            <a:srgbClr val="6246EA"/>
+          </a:solidFill>
+          <a:ln>
+            <a:noFill/>
+          </a:ln>
+        </p:spPr>
+        <p:style>
+          <a:lnRef idx="1">
+            <a:schemeClr val="accent1"/>
+          </a:lnRef>
+          <a:fillRef idx="3">
+            <a:schemeClr val="accent1"/>
+          </a:fillRef>
+          <a:effectRef idx="2">
+            <a:schemeClr val="accent1"/>
+          </a:effectRef>
+          <a:fontRef idx="minor">
+            <a:schemeClr val="lt1"/>
+          </a:fontRef>
+        </p:style>
+        <p:txBody>
+          <a:bodyPr rtlCol="0" anchor="ctr"/>
+          <a:lstStyle/>
+          <a:p>
+            <a:pPr algn="ctr"/>
+          </a:p>
+        </p:txBody>
+      </p:sp>
+      <p:sp>
+        <p:nvSpPr>
+          <p:cNvPr id="7" name="TextBox 6"/>
+          <p:cNvSpPr txBox="1"/>
+          <p:nvPr/>
+        </p:nvSpPr>
+        <p:spPr>
+          <a:xfrm>
+            <a:off x="1280160" y="2084831"/>
+            <a:ext cx="420624" cy="420624"/>
+          </a:xfrm>
+          <a:prstGeom prst="rect">
+            <a:avLst/>
+          </a:prstGeom>
+          <a:noFill/>
+        </p:spPr>
+        <p:txBody>
+          <a:bodyPr wrap="square" lIns="18288" rIns="18288" tIns="18288" bIns="18288" anchor="ctr">
+            <a:spAutoFit/>
+          </a:bodyPr>
+          <a:lstStyle/>
+          <a:p>
+            <a:pPr algn="ctr">
+              <a:lnSpc>
+                <a:spcPct val="108000"/>
+              </a:lnSpc>
+            </a:pPr>
+            <a:r>
+              <a:rPr sz="1300" b="1">
+                <a:solidFill>
+                  <a:srgbClr val="FFFFFF"/>
+                </a:solidFill>
+                <a:latin typeface="Malgun Gothic"/>
+              </a:rPr>
+              <a:t>1</a:t>
+            </a:r>
+          </a:p>
+        </p:txBody>
+      </p:sp>
+      <p:sp>
+        <p:nvSpPr>
+          <p:cNvPr id="8" name="TextBox 7"/>
+          <p:cNvSpPr txBox="1"/>
+          <p:nvPr/>
+        </p:nvSpPr>
+        <p:spPr>
+          <a:xfrm>
+            <a:off x="713232" y="2743200"/>
+            <a:ext cx="1581912" cy="274320"/>
+          </a:xfrm>
+          <a:prstGeom prst="rect">
+            <a:avLst/>
+          </a:prstGeom>
+          <a:noFill/>
+        </p:spPr>
+        <p:txBody>
+          <a:bodyPr wrap="square" lIns="18288" rIns="18288" tIns="18288" bIns="18288" anchor="t">
+            <a:spAutoFit/>
+          </a:bodyPr>
+          <a:lstStyle/>
+          <a:p>
+            <a:pPr algn="ctr">
+              <a:lnSpc>
+                <a:spcPct val="108000"/>
+              </a:lnSpc>
+            </a:pPr>
+            <a:r>
+              <a:rPr sz="1300" b="1">
+                <a:solidFill>
+                  <a:srgbClr val="FFFFFF"/>
+                </a:solidFill>
+                <a:latin typeface="Malgun Gothic"/>
+              </a:rPr>
+              <a:t>로그인</a:t>
+            </a:r>
+          </a:p>
+        </p:txBody>
+      </p:sp>
+      <p:sp>
+        <p:nvSpPr>
+          <p:cNvPr id="9" name="TextBox 8"/>
+          <p:cNvSpPr txBox="1"/>
+          <p:nvPr/>
+        </p:nvSpPr>
+        <p:spPr>
+          <a:xfrm>
+            <a:off x="713232" y="3182112"/>
+            <a:ext cx="1581912" cy="347472"/>
+          </a:xfrm>
+          <a:prstGeom prst="rect">
+            <a:avLst/>
+          </a:prstGeom>
+          <a:noFill/>
+        </p:spPr>
+        <p:txBody>
+          <a:bodyPr wrap="square" lIns="18288" rIns="18288" tIns="18288" bIns="18288" anchor="t">
+            <a:spAutoFit/>
+          </a:bodyPr>
+          <a:lstStyle/>
+          <a:p>
+            <a:pPr algn="ctr">
+              <a:lnSpc>
+                <a:spcPct val="108000"/>
+              </a:lnSpc>
+            </a:pPr>
+            <a:r>
+              <a:rPr sz="919" b="0">
+                <a:solidFill>
+                  <a:srgbClr val="CBD5E1"/>
+                </a:solidFill>
+                <a:latin typeface="Malgun Gothic"/>
+              </a:rPr>
+              <a:t>회원 계정으로 접속</a:t>
+            </a:r>
+          </a:p>
+        </p:txBody>
+      </p:sp>
+      <p:cxnSp>
+        <p:nvCxnSpPr>
+          <p:cNvPr id="10" name="Connector 9"/>
+          <p:cNvCxnSpPr/>
+          <p:nvPr/>
+        </p:nvCxnSpPr>
+        <p:spPr>
+          <a:xfrm>
+            <a:off x="2478024" y="2871216"/>
+            <a:ext cx="310896" cy="0"/>
+          </a:xfrm>
+          <a:prstGeom prst="line">
+            <a:avLst/>
+          </a:prstGeom>
+          <a:ln w="25400">
+            <a:solidFill>
+              <a:srgbClr val="A78BFA"/>
+            </a:solidFill>
+          </a:ln>
+        </p:spPr>
+        <p:style>
+          <a:lnRef idx="2">
+            <a:schemeClr val="accent1"/>
+          </a:lnRef>
+          <a:fillRef idx="0">
+            <a:schemeClr val="accent1"/>
+          </a:fillRef>
+          <a:effectRef idx="1">
+            <a:schemeClr val="accent1"/>
+          </a:effectRef>
+          <a:fontRef idx="minor">
+            <a:schemeClr val="tx1"/>
+          </a:fontRef>
+        </p:style>
+      </p:cxnSp>
+      <p:sp>
+        <p:nvSpPr>
+          <p:cNvPr id="11" name="Rounded Rectangle 10"/>
+          <p:cNvSpPr/>
+          <p:nvPr/>
+        </p:nvSpPr>
+        <p:spPr>
+          <a:xfrm>
+            <a:off x="2871216" y="1828800"/>
+            <a:ext cx="1947672" cy="2057400"/>
+          </a:xfrm>
+          <a:prstGeom prst="roundRect">
+            <a:avLst>
+              <a:gd name="adj" fmla="val 12000"/>
+            </a:avLst>
+          </a:prstGeom>
+          <a:solidFill>
+            <a:srgbClr val="182235"/>
+          </a:solidFill>
+          <a:ln w="12700">
+            <a:solidFill>
+              <a:srgbClr val="334155"/>
+            </a:solidFill>
+          </a:ln>
+        </p:spPr>
+        <p:style>
+          <a:lnRef idx="1">
+            <a:schemeClr val="accent1"/>
+          </a:lnRef>
+          <a:fillRef idx="3">
+            <a:schemeClr val="accent1"/>
+          </a:fillRef>
+          <a:effectRef idx="2">
+            <a:schemeClr val="accent1"/>
+          </a:effectRef>
+          <a:fontRef idx="minor">
+            <a:schemeClr val="lt1"/>
+          </a:fontRef>
+        </p:style>
+        <p:txBody>
+          <a:bodyPr rtlCol="0" anchor="ctr"/>
+          <a:lstStyle/>
+          <a:p>
+            <a:pPr algn="ctr"/>
+          </a:p>
+        </p:txBody>
+      </p:sp>
+      <p:sp>
+        <p:nvSpPr>
+          <p:cNvPr id="12" name="Oval 11"/>
+          <p:cNvSpPr/>
+          <p:nvPr/>
+        </p:nvSpPr>
+        <p:spPr>
+          <a:xfrm>
+            <a:off x="3621024" y="2084831"/>
+            <a:ext cx="420624" cy="420624"/>
+          </a:xfrm>
+          <a:prstGeom prst="ellipse">
+            <a:avLst/>
+          </a:prstGeom>
+          <a:solidFill>
+            <a:srgbClr val="8B5CF6"/>
+          </a:solidFill>
+          <a:ln>
+            <a:noFill/>
+          </a:ln>
+        </p:spPr>
+        <p:style>
+          <a:lnRef idx="1">
+            <a:schemeClr val="accent1"/>
+          </a:lnRef>
+          <a:fillRef idx="3">
+            <a:schemeClr val="accent1"/>
+          </a:fillRef>
+          <a:effectRef idx="2">
+            <a:schemeClr val="accent1"/>
+          </a:effectRef>
+          <a:fontRef idx="minor">
+            <a:schemeClr val="lt1"/>
+          </a:fontRef>
+        </p:style>
+        <p:txBody>
+          <a:bodyPr rtlCol="0" anchor="ctr"/>
+          <a:lstStyle/>
+          <a:p>
+            <a:pPr algn="ctr"/>
+          </a:p>
+        </p:txBody>
+      </p:sp>
+      <p:sp>
+        <p:nvSpPr>
+          <p:cNvPr id="13" name="TextBox 12"/>
+          <p:cNvSpPr txBox="1"/>
+          <p:nvPr/>
+        </p:nvSpPr>
+        <p:spPr>
+          <a:xfrm>
+            <a:off x="3621024" y="2084831"/>
+            <a:ext cx="420624" cy="420624"/>
+          </a:xfrm>
+          <a:prstGeom prst="rect">
+            <a:avLst/>
+          </a:prstGeom>
+          <a:noFill/>
+        </p:spPr>
+        <p:txBody>
+          <a:bodyPr wrap="square" lIns="18288" rIns="18288" tIns="18288" bIns="18288" anchor="ctr">
+            <a:spAutoFit/>
+          </a:bodyPr>
+          <a:lstStyle/>
+          <a:p>
+            <a:pPr algn="ctr">
+              <a:lnSpc>
+                <a:spcPct val="108000"/>
+              </a:lnSpc>
+            </a:pPr>
+            <a:r>
+              <a:rPr sz="1300" b="1">
+                <a:solidFill>
+                  <a:srgbClr val="FFFFFF"/>
+                </a:solidFill>
+                <a:latin typeface="Malgun Gothic"/>
+              </a:rPr>
+              <a:t>2</a:t>
+            </a:r>
+          </a:p>
+        </p:txBody>
+      </p:sp>
+      <p:sp>
+        <p:nvSpPr>
+          <p:cNvPr id="14" name="TextBox 13"/>
+          <p:cNvSpPr txBox="1"/>
+          <p:nvPr/>
+        </p:nvSpPr>
+        <p:spPr>
+          <a:xfrm>
+            <a:off x="3054096" y="2743200"/>
+            <a:ext cx="1581912" cy="274320"/>
+          </a:xfrm>
+          <a:prstGeom prst="rect">
+            <a:avLst/>
+          </a:prstGeom>
+          <a:noFill/>
+        </p:spPr>
+        <p:txBody>
+          <a:bodyPr wrap="square" lIns="18288" rIns="18288" tIns="18288" bIns="18288" anchor="t">
+            <a:spAutoFit/>
+          </a:bodyPr>
+          <a:lstStyle/>
+          <a:p>
+            <a:pPr algn="ctr">
+              <a:lnSpc>
+                <a:spcPct val="108000"/>
+              </a:lnSpc>
+            </a:pPr>
+            <a:r>
+              <a:rPr sz="1300" b="1">
+                <a:solidFill>
+                  <a:srgbClr val="FFFFFF"/>
+                </a:solidFill>
+                <a:latin typeface="Malgun Gothic"/>
+              </a:rPr>
+              <a:t>취향 저장</a:t>
+            </a:r>
+          </a:p>
+        </p:txBody>
+      </p:sp>
+      <p:sp>
+        <p:nvSpPr>
+          <p:cNvPr id="15" name="TextBox 14"/>
+          <p:cNvSpPr txBox="1"/>
+          <p:nvPr/>
+        </p:nvSpPr>
+        <p:spPr>
+          <a:xfrm>
+            <a:off x="3054096" y="3182112"/>
+            <a:ext cx="1581912" cy="347472"/>
+          </a:xfrm>
+          <a:prstGeom prst="rect">
+            <a:avLst/>
+          </a:prstGeom>
+          <a:noFill/>
+        </p:spPr>
+        <p:txBody>
+          <a:bodyPr wrap="square" lIns="18288" rIns="18288" tIns="18288" bIns="18288" anchor="t">
+            <a:spAutoFit/>
+          </a:bodyPr>
+          <a:lstStyle/>
+          <a:p>
+            <a:pPr algn="ctr">
+              <a:lnSpc>
+                <a:spcPct val="108000"/>
+              </a:lnSpc>
+            </a:pPr>
+            <a:r>
+              <a:rPr sz="919" b="0">
+                <a:solidFill>
+                  <a:srgbClr val="CBD5E1"/>
+                </a:solidFill>
+                <a:latin typeface="Malgun Gothic"/>
+              </a:rPr>
+              <a:t>관심 카테고리와 예산 선택</a:t>
+            </a:r>
+          </a:p>
+        </p:txBody>
+      </p:sp>
+      <p:cxnSp>
+        <p:nvCxnSpPr>
+          <p:cNvPr id="16" name="Connector 15"/>
+          <p:cNvCxnSpPr/>
+          <p:nvPr/>
+        </p:nvCxnSpPr>
+        <p:spPr>
+          <a:xfrm>
+            <a:off x="4818888" y="2871216"/>
+            <a:ext cx="310896" cy="0"/>
+          </a:xfrm>
+          <a:prstGeom prst="line">
+            <a:avLst/>
+          </a:prstGeom>
+          <a:ln w="25400">
+            <a:solidFill>
+              <a:srgbClr val="A78BFA"/>
+            </a:solidFill>
+          </a:ln>
+        </p:spPr>
+        <p:style>
+          <a:lnRef idx="2">
+            <a:schemeClr val="accent1"/>
+          </a:lnRef>
+          <a:fillRef idx="0">
+            <a:schemeClr val="accent1"/>
+          </a:fillRef>
+          <a:effectRef idx="1">
+            <a:schemeClr val="accent1"/>
+          </a:effectRef>
+          <a:fontRef idx="minor">
+            <a:schemeClr val="tx1"/>
+          </a:fontRef>
+        </p:style>
+      </p:cxnSp>
+      <p:sp>
+        <p:nvSpPr>
+          <p:cNvPr id="17" name="Rounded Rectangle 16"/>
+          <p:cNvSpPr/>
+          <p:nvPr/>
+        </p:nvSpPr>
+        <p:spPr>
+          <a:xfrm>
+            <a:off x="5212080" y="1828800"/>
+            <a:ext cx="1947672" cy="2057400"/>
+          </a:xfrm>
+          <a:prstGeom prst="roundRect">
+            <a:avLst>
+              <a:gd name="adj" fmla="val 12000"/>
+            </a:avLst>
+          </a:prstGeom>
+          <a:solidFill>
+            <a:srgbClr val="182235"/>
+          </a:solidFill>
+          <a:ln w="12700">
+            <a:solidFill>
+              <a:srgbClr val="334155"/>
+            </a:solidFill>
+          </a:ln>
+        </p:spPr>
+        <p:style>
+          <a:lnRef idx="1">
+            <a:schemeClr val="accent1"/>
+          </a:lnRef>
+          <a:fillRef idx="3">
+            <a:schemeClr val="accent1"/>
+          </a:fillRef>
+          <a:effectRef idx="2">
+            <a:schemeClr val="accent1"/>
+          </a:effectRef>
+          <a:fontRef idx="minor">
+            <a:schemeClr val="lt1"/>
+          </a:fontRef>
+        </p:style>
+        <p:txBody>
+          <a:bodyPr rtlCol="0" anchor="ctr"/>
+          <a:lstStyle/>
+          <a:p>
+            <a:pPr algn="ctr"/>
+          </a:p>
+        </p:txBody>
+      </p:sp>
+      <p:sp>
+        <p:nvSpPr>
+          <p:cNvPr id="18" name="Oval 17"/>
+          <p:cNvSpPr/>
+          <p:nvPr/>
+        </p:nvSpPr>
+        <p:spPr>
+          <a:xfrm>
+            <a:off x="5961888" y="2084831"/>
+            <a:ext cx="420624" cy="420624"/>
+          </a:xfrm>
+          <a:prstGeom prst="ellipse">
+            <a:avLst/>
+          </a:prstGeom>
+          <a:solidFill>
+            <a:srgbClr val="2563EB"/>
+          </a:solidFill>
+          <a:ln>
+            <a:noFill/>
+          </a:ln>
+        </p:spPr>
+        <p:style>
+          <a:lnRef idx="1">
+            <a:schemeClr val="accent1"/>
+          </a:lnRef>
+          <a:fillRef idx="3">
+            <a:schemeClr val="accent1"/>
+          </a:fillRef>
+          <a:effectRef idx="2">
+            <a:schemeClr val="accent1"/>
+          </a:effectRef>
+          <a:fontRef idx="minor">
+            <a:schemeClr val="lt1"/>
+          </a:fontRef>
+        </p:style>
+        <p:txBody>
+          <a:bodyPr rtlCol="0" anchor="ctr"/>
+          <a:lstStyle/>
+          <a:p>
+            <a:pPr algn="ctr"/>
+          </a:p>
+        </p:txBody>
+      </p:sp>
+      <p:sp>
+        <p:nvSpPr>
+          <p:cNvPr id="19" name="TextBox 18"/>
+          <p:cNvSpPr txBox="1"/>
+          <p:nvPr/>
+        </p:nvSpPr>
+        <p:spPr>
+          <a:xfrm>
+            <a:off x="5961888" y="2084831"/>
+            <a:ext cx="420624" cy="420624"/>
+          </a:xfrm>
+          <a:prstGeom prst="rect">
+            <a:avLst/>
+          </a:prstGeom>
+          <a:noFill/>
+        </p:spPr>
+        <p:txBody>
+          <a:bodyPr wrap="square" lIns="18288" rIns="18288" tIns="18288" bIns="18288" anchor="ctr">
+            <a:spAutoFit/>
+          </a:bodyPr>
+          <a:lstStyle/>
+          <a:p>
+            <a:pPr algn="ctr">
+              <a:lnSpc>
+                <a:spcPct val="108000"/>
+              </a:lnSpc>
+            </a:pPr>
+            <a:r>
+              <a:rPr sz="1300" b="1">
+                <a:solidFill>
+                  <a:srgbClr val="FFFFFF"/>
+                </a:solidFill>
+                <a:latin typeface="Malgun Gothic"/>
+              </a:rPr>
+              <a:t>3</a:t>
+            </a:r>
+          </a:p>
+        </p:txBody>
+      </p:sp>
+      <p:sp>
+        <p:nvSpPr>
+          <p:cNvPr id="20" name="TextBox 19"/>
+          <p:cNvSpPr txBox="1"/>
+          <p:nvPr/>
+        </p:nvSpPr>
+        <p:spPr>
+          <a:xfrm>
+            <a:off x="5394960" y="2743200"/>
+            <a:ext cx="1581912" cy="274320"/>
+          </a:xfrm>
+          <a:prstGeom prst="rect">
+            <a:avLst/>
+          </a:prstGeom>
+          <a:noFill/>
+        </p:spPr>
+        <p:txBody>
+          <a:bodyPr wrap="square" lIns="18288" rIns="18288" tIns="18288" bIns="18288" anchor="t">
+            <a:spAutoFit/>
+          </a:bodyPr>
+          <a:lstStyle/>
+          <a:p>
+            <a:pPr algn="ctr">
+              <a:lnSpc>
+                <a:spcPct val="108000"/>
+              </a:lnSpc>
+            </a:pPr>
+            <a:r>
+              <a:rPr sz="1300" b="1">
+                <a:solidFill>
+                  <a:srgbClr val="FFFFFF"/>
+                </a:solidFill>
+                <a:latin typeface="Malgun Gothic"/>
+              </a:rPr>
+              <a:t>상품 행동</a:t>
+            </a:r>
+          </a:p>
+        </p:txBody>
+      </p:sp>
+      <p:sp>
+        <p:nvSpPr>
+          <p:cNvPr id="21" name="TextBox 20"/>
+          <p:cNvSpPr txBox="1"/>
+          <p:nvPr/>
+        </p:nvSpPr>
+        <p:spPr>
+          <a:xfrm>
+            <a:off x="5394960" y="3182112"/>
+            <a:ext cx="1581912" cy="347472"/>
+          </a:xfrm>
+          <a:prstGeom prst="rect">
+            <a:avLst/>
+          </a:prstGeom>
+          <a:noFill/>
+        </p:spPr>
+        <p:txBody>
+          <a:bodyPr wrap="square" lIns="18288" rIns="18288" tIns="18288" bIns="18288" anchor="t">
+            <a:spAutoFit/>
+          </a:bodyPr>
+          <a:lstStyle/>
+          <a:p>
+            <a:pPr algn="ctr">
+              <a:lnSpc>
+                <a:spcPct val="108000"/>
+              </a:lnSpc>
+            </a:pPr>
+            <a:r>
+              <a:rPr sz="919" b="0">
+                <a:solidFill>
+                  <a:srgbClr val="CBD5E1"/>
+                </a:solidFill>
+                <a:latin typeface="Malgun Gothic"/>
+              </a:rPr>
+              <a:t>상품을 조회하고 찜·장바구니</a:t>
+            </a:r>
+          </a:p>
+        </p:txBody>
+      </p:sp>
+      <p:cxnSp>
+        <p:nvCxnSpPr>
+          <p:cNvPr id="22" name="Connector 21"/>
+          <p:cNvCxnSpPr/>
+          <p:nvPr/>
+        </p:nvCxnSpPr>
+        <p:spPr>
+          <a:xfrm>
+            <a:off x="7159752" y="2871216"/>
+            <a:ext cx="310896" cy="0"/>
+          </a:xfrm>
+          <a:prstGeom prst="line">
+            <a:avLst/>
+          </a:prstGeom>
+          <a:ln w="25400">
+            <a:solidFill>
+              <a:srgbClr val="A78BFA"/>
+            </a:solidFill>
+          </a:ln>
+        </p:spPr>
+        <p:style>
+          <a:lnRef idx="2">
+            <a:schemeClr val="accent1"/>
+          </a:lnRef>
+          <a:fillRef idx="0">
+            <a:schemeClr val="accent1"/>
+          </a:fillRef>
+          <a:effectRef idx="1">
+            <a:schemeClr val="accent1"/>
+          </a:effectRef>
+          <a:fontRef idx="minor">
+            <a:schemeClr val="tx1"/>
+          </a:fontRef>
+        </p:style>
+      </p:cxnSp>
+      <p:sp>
+        <p:nvSpPr>
+          <p:cNvPr id="23" name="Rounded Rectangle 22"/>
+          <p:cNvSpPr/>
+          <p:nvPr/>
+        </p:nvSpPr>
+        <p:spPr>
+          <a:xfrm>
+            <a:off x="7552944" y="1828800"/>
+            <a:ext cx="1947672" cy="2057400"/>
+          </a:xfrm>
+          <a:prstGeom prst="roundRect">
+            <a:avLst>
+              <a:gd name="adj" fmla="val 12000"/>
+            </a:avLst>
+          </a:prstGeom>
+          <a:solidFill>
+            <a:srgbClr val="182235"/>
+          </a:solidFill>
+          <a:ln w="12700">
+            <a:solidFill>
+              <a:srgbClr val="334155"/>
+            </a:solidFill>
+          </a:ln>
+        </p:spPr>
+        <p:style>
+          <a:lnRef idx="1">
+            <a:schemeClr val="accent1"/>
+          </a:lnRef>
+          <a:fillRef idx="3">
+            <a:schemeClr val="accent1"/>
+          </a:fillRef>
+          <a:effectRef idx="2">
+            <a:schemeClr val="accent1"/>
+          </a:effectRef>
+          <a:fontRef idx="minor">
+            <a:schemeClr val="lt1"/>
+          </a:fontRef>
+        </p:style>
+        <p:txBody>
+          <a:bodyPr rtlCol="0" anchor="ctr"/>
+          <a:lstStyle/>
+          <a:p>
+            <a:pPr algn="ctr"/>
+          </a:p>
+        </p:txBody>
+      </p:sp>
+      <p:sp>
+        <p:nvSpPr>
+          <p:cNvPr id="24" name="Oval 23"/>
+          <p:cNvSpPr/>
+          <p:nvPr/>
+        </p:nvSpPr>
+        <p:spPr>
+          <a:xfrm>
+            <a:off x="8302752" y="2084831"/>
+            <a:ext cx="420624" cy="420624"/>
+          </a:xfrm>
+          <a:prstGeom prst="ellipse">
+            <a:avLst/>
+          </a:prstGeom>
+          <a:solidFill>
+            <a:srgbClr val="D946A3"/>
+          </a:solidFill>
+          <a:ln>
+            <a:noFill/>
+          </a:ln>
+        </p:spPr>
+        <p:style>
+          <a:lnRef idx="1">
+            <a:schemeClr val="accent1"/>
+          </a:lnRef>
+          <a:fillRef idx="3">
+            <a:schemeClr val="accent1"/>
+          </a:fillRef>
+          <a:effectRef idx="2">
+            <a:schemeClr val="accent1"/>
+          </a:effectRef>
+          <a:fontRef idx="minor">
+            <a:schemeClr val="lt1"/>
+          </a:fontRef>
+        </p:style>
+        <p:txBody>
+          <a:bodyPr rtlCol="0" anchor="ctr"/>
+          <a:lstStyle/>
+          <a:p>
+            <a:pPr algn="ctr"/>
+          </a:p>
+        </p:txBody>
+      </p:sp>
+      <p:sp>
+        <p:nvSpPr>
+          <p:cNvPr id="25" name="TextBox 24"/>
+          <p:cNvSpPr txBox="1"/>
+          <p:nvPr/>
+        </p:nvSpPr>
+        <p:spPr>
+          <a:xfrm>
+            <a:off x="8302752" y="2084831"/>
+            <a:ext cx="420624" cy="420624"/>
+          </a:xfrm>
+          <a:prstGeom prst="rect">
+            <a:avLst/>
+          </a:prstGeom>
+          <a:noFill/>
+        </p:spPr>
+        <p:txBody>
+          <a:bodyPr wrap="square" lIns="18288" rIns="18288" tIns="18288" bIns="18288" anchor="ctr">
+            <a:spAutoFit/>
+          </a:bodyPr>
+          <a:lstStyle/>
+          <a:p>
+            <a:pPr algn="ctr">
+              <a:lnSpc>
+                <a:spcPct val="108000"/>
+              </a:lnSpc>
+            </a:pPr>
+            <a:r>
+              <a:rPr sz="1300" b="1">
+                <a:solidFill>
+                  <a:srgbClr val="FFFFFF"/>
+                </a:solidFill>
+                <a:latin typeface="Malgun Gothic"/>
+              </a:rPr>
+              <a:t>4</a:t>
+            </a:r>
+          </a:p>
+        </p:txBody>
+      </p:sp>
+      <p:sp>
+        <p:nvSpPr>
+          <p:cNvPr id="26" name="TextBox 25"/>
+          <p:cNvSpPr txBox="1"/>
+          <p:nvPr/>
+        </p:nvSpPr>
+        <p:spPr>
+          <a:xfrm>
+            <a:off x="7735823" y="2743200"/>
+            <a:ext cx="1581912" cy="274320"/>
+          </a:xfrm>
+          <a:prstGeom prst="rect">
+            <a:avLst/>
+          </a:prstGeom>
+          <a:noFill/>
+        </p:spPr>
+        <p:txBody>
+          <a:bodyPr wrap="square" lIns="18288" rIns="18288" tIns="18288" bIns="18288" anchor="t">
+            <a:spAutoFit/>
+          </a:bodyPr>
+          <a:lstStyle/>
+          <a:p>
+            <a:pPr algn="ctr">
+              <a:lnSpc>
+                <a:spcPct val="108000"/>
+              </a:lnSpc>
+            </a:pPr>
+            <a:r>
+              <a:rPr sz="1300" b="1">
+                <a:solidFill>
+                  <a:srgbClr val="FFFFFF"/>
+                </a:solidFill>
+                <a:latin typeface="Malgun Gothic"/>
+              </a:rPr>
+              <a:t>AI 추천</a:t>
+            </a:r>
+          </a:p>
+        </p:txBody>
+      </p:sp>
+      <p:sp>
+        <p:nvSpPr>
+          <p:cNvPr id="27" name="TextBox 26"/>
+          <p:cNvSpPr txBox="1"/>
+          <p:nvPr/>
+        </p:nvSpPr>
+        <p:spPr>
+          <a:xfrm>
+            <a:off x="7735823" y="3182112"/>
+            <a:ext cx="1581912" cy="347472"/>
+          </a:xfrm>
+          <a:prstGeom prst="rect">
+            <a:avLst/>
+          </a:prstGeom>
+          <a:noFill/>
+        </p:spPr>
+        <p:txBody>
+          <a:bodyPr wrap="square" lIns="18288" rIns="18288" tIns="18288" bIns="18288" anchor="t">
+            <a:spAutoFit/>
+          </a:bodyPr>
+          <a:lstStyle/>
+          <a:p>
+            <a:pPr algn="ctr">
+              <a:lnSpc>
+                <a:spcPct val="108000"/>
+              </a:lnSpc>
+            </a:pPr>
+            <a:r>
+              <a:rPr sz="919" b="0">
+                <a:solidFill>
+                  <a:srgbClr val="CBD5E1"/>
+                </a:solidFill>
+                <a:latin typeface="Malgun Gothic"/>
+              </a:rPr>
+              <a:t>추천 결과와 이유 확인</a:t>
+            </a:r>
+          </a:p>
+        </p:txBody>
+      </p:sp>
+      <p:cxnSp>
+        <p:nvCxnSpPr>
+          <p:cNvPr id="28" name="Connector 27"/>
+          <p:cNvCxnSpPr/>
+          <p:nvPr/>
+        </p:nvCxnSpPr>
+        <p:spPr>
+          <a:xfrm>
+            <a:off x="9500616" y="2871216"/>
+            <a:ext cx="310896" cy="0"/>
+          </a:xfrm>
+          <a:prstGeom prst="line">
+            <a:avLst/>
+          </a:prstGeom>
+          <a:ln w="25400">
+            <a:solidFill>
+              <a:srgbClr val="A78BFA"/>
+            </a:solidFill>
+          </a:ln>
+        </p:spPr>
+        <p:style>
+          <a:lnRef idx="2">
+            <a:schemeClr val="accent1"/>
+          </a:lnRef>
+          <a:fillRef idx="0">
+            <a:schemeClr val="accent1"/>
+          </a:fillRef>
+          <a:effectRef idx="1">
+            <a:schemeClr val="accent1"/>
+          </a:effectRef>
+          <a:fontRef idx="minor">
+            <a:schemeClr val="tx1"/>
+          </a:fontRef>
+        </p:style>
+      </p:cxnSp>
+      <p:sp>
+        <p:nvSpPr>
+          <p:cNvPr id="29" name="Rounded Rectangle 28"/>
+          <p:cNvSpPr/>
+          <p:nvPr/>
+        </p:nvSpPr>
+        <p:spPr>
+          <a:xfrm>
+            <a:off x="9893808" y="1828800"/>
+            <a:ext cx="1947672" cy="2057400"/>
+          </a:xfrm>
+          <a:prstGeom prst="roundRect">
+            <a:avLst>
+              <a:gd name="adj" fmla="val 12000"/>
+            </a:avLst>
+          </a:prstGeom>
+          <a:solidFill>
+            <a:srgbClr val="182235"/>
+          </a:solidFill>
+          <a:ln w="12700">
+            <a:solidFill>
+              <a:srgbClr val="334155"/>
+            </a:solidFill>
+          </a:ln>
+        </p:spPr>
+        <p:style>
+          <a:lnRef idx="1">
+            <a:schemeClr val="accent1"/>
+          </a:lnRef>
+          <a:fillRef idx="3">
+            <a:schemeClr val="accent1"/>
+          </a:fillRef>
+          <a:effectRef idx="2">
+            <a:schemeClr val="accent1"/>
+          </a:effectRef>
+          <a:fontRef idx="minor">
+            <a:schemeClr val="lt1"/>
+          </a:fontRef>
+        </p:style>
+        <p:txBody>
+          <a:bodyPr rtlCol="0" anchor="ctr"/>
+          <a:lstStyle/>
+          <a:p>
+            <a:pPr algn="ctr"/>
+          </a:p>
+        </p:txBody>
+      </p:sp>
+      <p:sp>
+        <p:nvSpPr>
+          <p:cNvPr id="30" name="Oval 29"/>
+          <p:cNvSpPr/>
+          <p:nvPr/>
+        </p:nvSpPr>
+        <p:spPr>
+          <a:xfrm>
+            <a:off x="10643616" y="2084831"/>
+            <a:ext cx="420624" cy="420624"/>
+          </a:xfrm>
+          <a:prstGeom prst="ellipse">
+            <a:avLst/>
+          </a:prstGeom>
+          <a:solidFill>
+            <a:srgbClr val="16A34A"/>
+          </a:solidFill>
+          <a:ln>
+            <a:noFill/>
+          </a:ln>
+        </p:spPr>
+        <p:style>
+          <a:lnRef idx="1">
+            <a:schemeClr val="accent1"/>
+          </a:lnRef>
+          <a:fillRef idx="3">
+            <a:schemeClr val="accent1"/>
+          </a:fillRef>
+          <a:effectRef idx="2">
+            <a:schemeClr val="accent1"/>
+          </a:effectRef>
+          <a:fontRef idx="minor">
+            <a:schemeClr val="lt1"/>
+          </a:fontRef>
+        </p:style>
+        <p:txBody>
+          <a:bodyPr rtlCol="0" anchor="ctr"/>
+          <a:lstStyle/>
+          <a:p>
+            <a:pPr algn="ctr"/>
+          </a:p>
+        </p:txBody>
+      </p:sp>
+      <p:sp>
+        <p:nvSpPr>
+          <p:cNvPr id="31" name="TextBox 30"/>
+          <p:cNvSpPr txBox="1"/>
+          <p:nvPr/>
+        </p:nvSpPr>
+        <p:spPr>
+          <a:xfrm>
+            <a:off x="10643616" y="2084831"/>
+            <a:ext cx="420624" cy="420624"/>
+          </a:xfrm>
+          <a:prstGeom prst="rect">
+            <a:avLst/>
+          </a:prstGeom>
+          <a:noFill/>
+        </p:spPr>
+        <p:txBody>
+          <a:bodyPr wrap="square" lIns="18288" rIns="18288" tIns="18288" bIns="18288" anchor="ctr">
+            <a:spAutoFit/>
+          </a:bodyPr>
+          <a:lstStyle/>
+          <a:p>
+            <a:pPr algn="ctr">
+              <a:lnSpc>
+                <a:spcPct val="108000"/>
+              </a:lnSpc>
+            </a:pPr>
+            <a:r>
+              <a:rPr sz="1300" b="1">
+                <a:solidFill>
+                  <a:srgbClr val="FFFFFF"/>
+                </a:solidFill>
+                <a:latin typeface="Malgun Gothic"/>
+              </a:rPr>
+              <a:t>5</a:t>
+            </a:r>
+          </a:p>
+        </p:txBody>
+      </p:sp>
+      <p:sp>
+        <p:nvSpPr>
+          <p:cNvPr id="32" name="TextBox 31"/>
+          <p:cNvSpPr txBox="1"/>
+          <p:nvPr/>
+        </p:nvSpPr>
+        <p:spPr>
+          <a:xfrm>
+            <a:off x="10076688" y="2743200"/>
+            <a:ext cx="1581912" cy="274320"/>
+          </a:xfrm>
+          <a:prstGeom prst="rect">
+            <a:avLst/>
+          </a:prstGeom>
+          <a:noFill/>
+        </p:spPr>
+        <p:txBody>
+          <a:bodyPr wrap="square" lIns="18288" rIns="18288" tIns="18288" bIns="18288" anchor="t">
+            <a:spAutoFit/>
+          </a:bodyPr>
+          <a:lstStyle/>
+          <a:p>
+            <a:pPr algn="ctr">
+              <a:lnSpc>
+                <a:spcPct val="108000"/>
+              </a:lnSpc>
+            </a:pPr>
+            <a:r>
+              <a:rPr sz="1300" b="1">
+                <a:solidFill>
+                  <a:srgbClr val="FFFFFF"/>
+                </a:solidFill>
+                <a:latin typeface="Malgun Gothic"/>
+              </a:rPr>
+              <a:t>모의 결제</a:t>
+            </a:r>
+          </a:p>
+        </p:txBody>
+      </p:sp>
+      <p:sp>
+        <p:nvSpPr>
+          <p:cNvPr id="33" name="TextBox 32"/>
+          <p:cNvSpPr txBox="1"/>
+          <p:nvPr/>
+        </p:nvSpPr>
+        <p:spPr>
+          <a:xfrm>
+            <a:off x="10076688" y="3182112"/>
+            <a:ext cx="1581912" cy="347472"/>
+          </a:xfrm>
+          <a:prstGeom prst="rect">
+            <a:avLst/>
+          </a:prstGeom>
+          <a:noFill/>
+        </p:spPr>
+        <p:txBody>
+          <a:bodyPr wrap="square" lIns="18288" rIns="18288" tIns="18288" bIns="18288" anchor="t">
+            <a:spAutoFit/>
+          </a:bodyPr>
+          <a:lstStyle/>
+          <a:p>
+            <a:pPr algn="ctr">
+              <a:lnSpc>
+                <a:spcPct val="108000"/>
+              </a:lnSpc>
+            </a:pPr>
+            <a:r>
+              <a:rPr sz="919" b="0">
+                <a:solidFill>
+                  <a:srgbClr val="CBD5E1"/>
+                </a:solidFill>
+                <a:latin typeface="Malgun Gothic"/>
+              </a:rPr>
+              <a:t>재고 차감과 주문 내역 확인</a:t>
+            </a:r>
+          </a:p>
+        </p:txBody>
+      </p:sp>
+      <p:sp>
+        <p:nvSpPr>
+          <p:cNvPr id="34" name="Rounded Rectangle 33"/>
+          <p:cNvSpPr/>
+          <p:nvPr/>
+        </p:nvSpPr>
+        <p:spPr>
+          <a:xfrm>
+            <a:off x="1143000" y="4389120"/>
+            <a:ext cx="9902952" cy="914400"/>
+          </a:xfrm>
+          <a:prstGeom prst="roundRect">
+            <a:avLst>
+              <a:gd name="adj" fmla="val 12000"/>
+            </a:avLst>
+          </a:prstGeom>
+          <a:solidFill>
+            <a:srgbClr val="302B63"/>
+          </a:solidFill>
+          <a:ln w="12700">
+            <a:solidFill>
+              <a:srgbClr val="4C3F91"/>
+            </a:solidFill>
+          </a:ln>
+        </p:spPr>
+        <p:style>
+          <a:lnRef idx="1">
+            <a:schemeClr val="accent1"/>
+          </a:lnRef>
+          <a:fillRef idx="3">
+            <a:schemeClr val="accent1"/>
+          </a:fillRef>
+          <a:effectRef idx="2">
+            <a:schemeClr val="accent1"/>
+          </a:effectRef>
+          <a:fontRef idx="minor">
+            <a:schemeClr val="lt1"/>
+          </a:fontRef>
+        </p:style>
+        <p:txBody>
+          <a:bodyPr rtlCol="0" anchor="ctr"/>
+          <a:lstStyle/>
+          <a:p>
+            <a:pPr algn="ctr"/>
+          </a:p>
+        </p:txBody>
+      </p:sp>
+      <p:sp>
+        <p:nvSpPr>
+          <p:cNvPr id="35" name="TextBox 34"/>
+          <p:cNvSpPr txBox="1"/>
+          <p:nvPr/>
+        </p:nvSpPr>
+        <p:spPr>
+          <a:xfrm>
+            <a:off x="1444752" y="4590288"/>
+            <a:ext cx="9281160" cy="502920"/>
+          </a:xfrm>
+          <a:prstGeom prst="rect">
+            <a:avLst/>
+          </a:prstGeom>
+          <a:noFill/>
+        </p:spPr>
+        <p:txBody>
+          <a:bodyPr wrap="square" lIns="18288" rIns="18288" tIns="18288" bIns="18288" anchor="t">
+            <a:spAutoFit/>
+          </a:bodyPr>
+          <a:lstStyle/>
+          <a:p>
+            <a:pPr algn="ctr">
+              <a:lnSpc>
+                <a:spcPct val="108000"/>
+              </a:lnSpc>
+            </a:pPr>
+            <a:r>
+              <a:rPr sz="1400" b="1">
+                <a:solidFill>
+                  <a:srgbClr val="FFFFFF"/>
+                </a:solidFill>
+                <a:latin typeface="Malgun Gothic"/>
+              </a:rPr>
+              <a:t>마무리 문장  |  “사용자의 행동을 이해하고, 추천 이유를 설명하며,
+실제 주문 흐름까지 연결되는 AI 이커머스를 구현했습니다.”</a:t>
+            </a:r>
+          </a:p>
+        </p:txBody>
+      </p:sp>
+      <p:sp>
+        <p:nvSpPr>
+          <p:cNvPr id="36" name="TextBox 35"/>
+          <p:cNvSpPr txBox="1"/>
+          <p:nvPr/>
+        </p:nvSpPr>
+        <p:spPr>
+          <a:xfrm>
+            <a:off x="1920240" y="5852160"/>
+            <a:ext cx="8321040" cy="274320"/>
+          </a:xfrm>
+          <a:prstGeom prst="rect">
+            <a:avLst/>
+          </a:prstGeom>
+          <a:noFill/>
+        </p:spPr>
+        <p:txBody>
+          <a:bodyPr wrap="square" lIns="18288" rIns="18288" tIns="18288" bIns="18288" anchor="t">
+            <a:spAutoFit/>
+          </a:bodyPr>
+          <a:lstStyle/>
+          <a:p>
+            <a:pPr algn="ctr">
+              <a:lnSpc>
+                <a:spcPct val="108000"/>
+              </a:lnSpc>
+            </a:pPr>
+            <a:r>
+              <a:rPr sz="1000" b="1">
+                <a:solidFill>
+                  <a:srgbClr val="A78BFA"/>
+                </a:solidFill>
+                <a:latin typeface="Malgun Gothic"/>
+              </a:rPr>
+              <a:t>시연 중 오류가 나더라도 핵심은 ‘행동이 저장되고 다음 추천에 반영된다’는 점을 설명하면 됩니다.</a:t>
+            </a:r>
+          </a:p>
+        </p:txBody>
+      </p:sp>
+      <p:sp>
+        <p:nvSpPr>
+          <p:cNvPr id="37" name="TextBox 36"/>
+          <p:cNvSpPr txBox="1"/>
+          <p:nvPr/>
+        </p:nvSpPr>
+        <p:spPr>
+          <a:xfrm>
+            <a:off x="11109960" y="6473952"/>
+            <a:ext cx="438912" cy="228600"/>
+          </a:xfrm>
+          <a:prstGeom prst="rect">
+            <a:avLst/>
+          </a:prstGeom>
+          <a:noFill/>
+        </p:spPr>
+        <p:txBody>
+          <a:bodyPr wrap="square" lIns="18288" rIns="18288" tIns="18288" bIns="18288" anchor="t">
+            <a:spAutoFit/>
+          </a:bodyPr>
+          <a:lstStyle/>
+          <a:p>
+            <a:pPr algn="r">
+              <a:lnSpc>
+                <a:spcPct val="108000"/>
+              </a:lnSpc>
+            </a:pPr>
+            <a:r>
+              <a:rPr sz="900" b="1">
+                <a:solidFill>
+                  <a:srgbClr val="94A3B8"/>
+                </a:solidFill>
+                <a:latin typeface="Malgun Gothic"/>
+              </a:rPr>
+              <a:t>20</a:t>
             </a:r>
           </a:p>
         </p:txBody>

</xml_diff>